<commit_message>
Built site for gh-pages
</commit_message>
<xml_diff>
--- a/02-projects/pharos-cy-wp3-outline-short.pptx
+++ b/02-projects/pharos-cy-wp3-outline-short.pptx
@@ -112,6 +112,916 @@
     </a:lvl9pPr>
   </p:defaultTextStyle>
 </p:presentation>
+</file>
+
+<file path=ppt/notesMasters/notesMaster1.xml><?xml version="1.0" encoding="utf-8"?>
+<p:notesMaster xmlns:a="http://schemas.openxmlformats.org/drawingml/2006/main" xmlns:p="http://schemas.openxmlformats.org/presentationml/2006/main" xmlns:r="http://schemas.openxmlformats.org/officeDocument/2006/relationships">
+  <p:cSld>
+    <p:bg>
+      <p:bgRef idx="1001">
+        <a:schemeClr val="bg1"/>
+      </p:bgRef>
+    </p:bg>
+    <p:spTree>
+      <p:nvGrpSpPr>
+        <p:cNvPr id="1" name=""/>
+        <p:cNvGrpSpPr/>
+        <p:nvPr/>
+      </p:nvGrpSpPr>
+      <p:grpSpPr>
+        <a:xfrm>
+          <a:off x="0" y="0"/>
+          <a:ext cx="0" cy="0"/>
+          <a:chOff x="0" y="0"/>
+          <a:chExt cx="0" cy="0"/>
+        </a:xfrm>
+      </p:grpSpPr>
+      <p:sp>
+        <p:nvSpPr>
+          <p:cNvPr id="2" name="Header Placeholder 1"/>
+          <p:cNvSpPr>
+            <a:spLocks noGrp="1"/>
+          </p:cNvSpPr>
+          <p:nvPr>
+            <p:ph type="hdr" sz="quarter"/>
+          </p:nvPr>
+        </p:nvSpPr>
+        <p:spPr>
+          <a:xfrm>
+            <a:off x="0" y="0"/>
+            <a:ext cx="2971800" cy="457200"/>
+          </a:xfrm>
+          <a:prstGeom prst="rect">
+            <a:avLst/>
+          </a:prstGeom>
+        </p:spPr>
+        <p:txBody>
+          <a:bodyPr vert="horz" lIns="91440" tIns="45720" rIns="91440" bIns="45720" rtlCol="0"/>
+          <a:lstStyle>
+            <a:lvl1pPr algn="l">
+              <a:defRPr sz="1200"/>
+            </a:lvl1pPr>
+          </a:lstStyle>
+          <a:p>
+            <a:endParaRPr lang="en-US"/>
+          </a:p>
+        </p:txBody>
+      </p:sp>
+      <p:sp>
+        <p:nvSpPr>
+          <p:cNvPr id="3" name="Date Placeholder 2"/>
+          <p:cNvSpPr>
+            <a:spLocks noGrp="1"/>
+          </p:cNvSpPr>
+          <p:nvPr>
+            <p:ph type="dt" idx="1"/>
+          </p:nvPr>
+        </p:nvSpPr>
+        <p:spPr>
+          <a:xfrm>
+            <a:off x="3884613" y="0"/>
+            <a:ext cx="2971800" cy="457200"/>
+          </a:xfrm>
+          <a:prstGeom prst="rect">
+            <a:avLst/>
+          </a:prstGeom>
+        </p:spPr>
+        <p:txBody>
+          <a:bodyPr vert="horz" lIns="91440" tIns="45720" rIns="91440" bIns="45720" rtlCol="0"/>
+          <a:lstStyle>
+            <a:lvl1pPr algn="r">
+              <a:defRPr sz="1200"/>
+            </a:lvl1pPr>
+          </a:lstStyle>
+          <a:p>
+            <a:fld id="{0F89C1C7-3DCD-1040-A9CF-14679D8B5DDD}" type="datetimeFigureOut">
+              <a:rPr lang="en-US" smtClean="0"/>
+              <a:t>10/17/16</a:t>
+            </a:fld>
+            <a:endParaRPr lang="en-US"/>
+          </a:p>
+        </p:txBody>
+      </p:sp>
+      <p:sp>
+        <p:nvSpPr>
+          <p:cNvPr id="4" name="Slide Image Placeholder 3"/>
+          <p:cNvSpPr>
+            <a:spLocks noGrp="1" noRot="1" noChangeAspect="1"/>
+          </p:cNvSpPr>
+          <p:nvPr>
+            <p:ph type="sldImg" idx="2"/>
+          </p:nvPr>
+        </p:nvSpPr>
+        <p:spPr>
+          <a:xfrm>
+            <a:off x="1143000" y="685800"/>
+            <a:ext cx="4572000" cy="3429000"/>
+          </a:xfrm>
+          <a:prstGeom prst="rect">
+            <a:avLst/>
+          </a:prstGeom>
+          <a:noFill/>
+          <a:ln w="12700">
+            <a:solidFill>
+              <a:prstClr val="black"/>
+            </a:solidFill>
+          </a:ln>
+        </p:spPr>
+        <p:txBody>
+          <a:bodyPr vert="horz" lIns="91440" tIns="45720" rIns="91440" bIns="45720" rtlCol="0" anchor="ctr"/>
+          <a:lstStyle/>
+          <a:p>
+            <a:endParaRPr lang="en-US"/>
+          </a:p>
+        </p:txBody>
+      </p:sp>
+      <p:sp>
+        <p:nvSpPr>
+          <p:cNvPr id="5" name="Notes Placeholder 4"/>
+          <p:cNvSpPr>
+            <a:spLocks noGrp="1"/>
+          </p:cNvSpPr>
+          <p:nvPr>
+            <p:ph type="body" sz="quarter" idx="3"/>
+          </p:nvPr>
+        </p:nvSpPr>
+        <p:spPr>
+          <a:xfrm>
+            <a:off x="685800" y="4343400"/>
+            <a:ext cx="5486400" cy="4114800"/>
+          </a:xfrm>
+          <a:prstGeom prst="rect">
+            <a:avLst/>
+          </a:prstGeom>
+        </p:spPr>
+        <p:txBody>
+          <a:bodyPr vert="horz" lIns="91440" tIns="45720" rIns="91440" bIns="45720" rtlCol="0"/>
+          <a:lstStyle/>
+          <a:p>
+            <a:pPr lvl="0"/>
+            <a:r>
+              <a:rPr lang="en-US" smtClean="0"/>
+              <a:t>Click to edit Master text styles</a:t>
+            </a:r>
+          </a:p>
+          <a:p>
+            <a:pPr lvl="1"/>
+            <a:r>
+              <a:rPr lang="en-US" smtClean="0"/>
+              <a:t>Second level</a:t>
+            </a:r>
+          </a:p>
+          <a:p>
+            <a:pPr lvl="2"/>
+            <a:r>
+              <a:rPr lang="en-US" smtClean="0"/>
+              <a:t>Third level</a:t>
+            </a:r>
+          </a:p>
+          <a:p>
+            <a:pPr lvl="3"/>
+            <a:r>
+              <a:rPr lang="en-US" smtClean="0"/>
+              <a:t>Fourth level</a:t>
+            </a:r>
+          </a:p>
+          <a:p>
+            <a:pPr lvl="4"/>
+            <a:r>
+              <a:rPr lang="en-US" smtClean="0"/>
+              <a:t>Fifth level</a:t>
+            </a:r>
+            <a:endParaRPr lang="en-US"/>
+          </a:p>
+        </p:txBody>
+      </p:sp>
+      <p:sp>
+        <p:nvSpPr>
+          <p:cNvPr id="6" name="Footer Placeholder 5"/>
+          <p:cNvSpPr>
+            <a:spLocks noGrp="1"/>
+          </p:cNvSpPr>
+          <p:nvPr>
+            <p:ph type="ftr" sz="quarter" idx="4"/>
+          </p:nvPr>
+        </p:nvSpPr>
+        <p:spPr>
+          <a:xfrm>
+            <a:off x="0" y="8685213"/>
+            <a:ext cx="2971800" cy="457200"/>
+          </a:xfrm>
+          <a:prstGeom prst="rect">
+            <a:avLst/>
+          </a:prstGeom>
+        </p:spPr>
+        <p:txBody>
+          <a:bodyPr vert="horz" lIns="91440" tIns="45720" rIns="91440" bIns="45720" rtlCol="0" anchor="b"/>
+          <a:lstStyle>
+            <a:lvl1pPr algn="l">
+              <a:defRPr sz="1200"/>
+            </a:lvl1pPr>
+          </a:lstStyle>
+          <a:p>
+            <a:endParaRPr lang="en-US"/>
+          </a:p>
+        </p:txBody>
+      </p:sp>
+      <p:sp>
+        <p:nvSpPr>
+          <p:cNvPr id="7" name="Slide Number Placeholder 6"/>
+          <p:cNvSpPr>
+            <a:spLocks noGrp="1"/>
+          </p:cNvSpPr>
+          <p:nvPr>
+            <p:ph type="sldNum" sz="quarter" idx="5"/>
+          </p:nvPr>
+        </p:nvSpPr>
+        <p:spPr>
+          <a:xfrm>
+            <a:off x="3884613" y="8685213"/>
+            <a:ext cx="2971800" cy="457200"/>
+          </a:xfrm>
+          <a:prstGeom prst="rect">
+            <a:avLst/>
+          </a:prstGeom>
+        </p:spPr>
+        <p:txBody>
+          <a:bodyPr vert="horz" lIns="91440" tIns="45720" rIns="91440" bIns="45720" rtlCol="0" anchor="b"/>
+          <a:lstStyle>
+            <a:lvl1pPr algn="r">
+              <a:defRPr sz="1200"/>
+            </a:lvl1pPr>
+          </a:lstStyle>
+          <a:p>
+            <a:fld id="{BB5E49A5-4136-284D-997B-48E1D791AD67}" type="slidenum">
+              <a:rPr lang="en-US" smtClean="0"/>
+              <a:t>‹#›</a:t>
+            </a:fld>
+            <a:endParaRPr lang="en-US"/>
+          </a:p>
+        </p:txBody>
+      </p:sp>
+    </p:spTree>
+    <p:extLst>
+      <p:ext uri="{BB962C8B-B14F-4D97-AF65-F5344CB8AC3E}">
+        <p14:creationId xmlns:p14="http://schemas.microsoft.com/office/powerpoint/2010/main" val="2623252185"/>
+      </p:ext>
+    </p:extLst>
+  </p:cSld>
+  <p:clrMap bg1="lt1" tx1="dk1" bg2="lt2" tx2="dk2" accent1="accent1" accent2="accent2" accent3="accent3" accent4="accent4" accent5="accent5" accent6="accent6" hlink="hlink" folHlink="folHlink"/>
+  <p:notesStyle>
+    <a:lvl1pPr marL="0" algn="l" defTabSz="457200" rtl="0" eaLnBrk="1" latinLnBrk="0" hangingPunct="1">
+      <a:defRPr sz="1200" kern="1200">
+        <a:solidFill>
+          <a:schemeClr val="tx1"/>
+        </a:solidFill>
+        <a:latin typeface="+mn-lt"/>
+        <a:ea typeface="+mn-ea"/>
+        <a:cs typeface="+mn-cs"/>
+      </a:defRPr>
+    </a:lvl1pPr>
+    <a:lvl2pPr marL="457200" algn="l" defTabSz="457200" rtl="0" eaLnBrk="1" latinLnBrk="0" hangingPunct="1">
+      <a:defRPr sz="1200" kern="1200">
+        <a:solidFill>
+          <a:schemeClr val="tx1"/>
+        </a:solidFill>
+        <a:latin typeface="+mn-lt"/>
+        <a:ea typeface="+mn-ea"/>
+        <a:cs typeface="+mn-cs"/>
+      </a:defRPr>
+    </a:lvl2pPr>
+    <a:lvl3pPr marL="914400" algn="l" defTabSz="457200" rtl="0" eaLnBrk="1" latinLnBrk="0" hangingPunct="1">
+      <a:defRPr sz="1200" kern="1200">
+        <a:solidFill>
+          <a:schemeClr val="tx1"/>
+        </a:solidFill>
+        <a:latin typeface="+mn-lt"/>
+        <a:ea typeface="+mn-ea"/>
+        <a:cs typeface="+mn-cs"/>
+      </a:defRPr>
+    </a:lvl3pPr>
+    <a:lvl4pPr marL="1371600" algn="l" defTabSz="457200" rtl="0" eaLnBrk="1" latinLnBrk="0" hangingPunct="1">
+      <a:defRPr sz="1200" kern="1200">
+        <a:solidFill>
+          <a:schemeClr val="tx1"/>
+        </a:solidFill>
+        <a:latin typeface="+mn-lt"/>
+        <a:ea typeface="+mn-ea"/>
+        <a:cs typeface="+mn-cs"/>
+      </a:defRPr>
+    </a:lvl4pPr>
+    <a:lvl5pPr marL="1828800" algn="l" defTabSz="457200" rtl="0" eaLnBrk="1" latinLnBrk="0" hangingPunct="1">
+      <a:defRPr sz="1200" kern="1200">
+        <a:solidFill>
+          <a:schemeClr val="tx1"/>
+        </a:solidFill>
+        <a:latin typeface="+mn-lt"/>
+        <a:ea typeface="+mn-ea"/>
+        <a:cs typeface="+mn-cs"/>
+      </a:defRPr>
+    </a:lvl5pPr>
+    <a:lvl6pPr marL="2286000" algn="l" defTabSz="457200" rtl="0" eaLnBrk="1" latinLnBrk="0" hangingPunct="1">
+      <a:defRPr sz="1200" kern="1200">
+        <a:solidFill>
+          <a:schemeClr val="tx1"/>
+        </a:solidFill>
+        <a:latin typeface="+mn-lt"/>
+        <a:ea typeface="+mn-ea"/>
+        <a:cs typeface="+mn-cs"/>
+      </a:defRPr>
+    </a:lvl6pPr>
+    <a:lvl7pPr marL="2743200" algn="l" defTabSz="457200" rtl="0" eaLnBrk="1" latinLnBrk="0" hangingPunct="1">
+      <a:defRPr sz="1200" kern="1200">
+        <a:solidFill>
+          <a:schemeClr val="tx1"/>
+        </a:solidFill>
+        <a:latin typeface="+mn-lt"/>
+        <a:ea typeface="+mn-ea"/>
+        <a:cs typeface="+mn-cs"/>
+      </a:defRPr>
+    </a:lvl7pPr>
+    <a:lvl8pPr marL="3200400" algn="l" defTabSz="457200" rtl="0" eaLnBrk="1" latinLnBrk="0" hangingPunct="1">
+      <a:defRPr sz="1200" kern="1200">
+        <a:solidFill>
+          <a:schemeClr val="tx1"/>
+        </a:solidFill>
+        <a:latin typeface="+mn-lt"/>
+        <a:ea typeface="+mn-ea"/>
+        <a:cs typeface="+mn-cs"/>
+      </a:defRPr>
+    </a:lvl8pPr>
+    <a:lvl9pPr marL="3657600" algn="l" defTabSz="457200" rtl="0" eaLnBrk="1" latinLnBrk="0" hangingPunct="1">
+      <a:defRPr sz="1200" kern="1200">
+        <a:solidFill>
+          <a:schemeClr val="tx1"/>
+        </a:solidFill>
+        <a:latin typeface="+mn-lt"/>
+        <a:ea typeface="+mn-ea"/>
+        <a:cs typeface="+mn-cs"/>
+      </a:defRPr>
+    </a:lvl9pPr>
+  </p:notesStyle>
+</p:notesMaster>
+</file>
+
+<file path=ppt/notesSlides/notesSlide1.xml><?xml version="1.0" encoding="utf-8"?>
+<p:notes xmlns:a="http://schemas.openxmlformats.org/drawingml/2006/main" xmlns:p="http://schemas.openxmlformats.org/presentationml/2006/main" xmlns:r="http://schemas.openxmlformats.org/officeDocument/2006/relationships">
+  <p:cSld>
+    <p:spTree>
+      <p:nvGrpSpPr>
+        <p:cNvPr id="1" name=""/>
+        <p:cNvGrpSpPr/>
+        <p:nvPr/>
+      </p:nvGrpSpPr>
+      <p:grpSpPr>
+        <a:xfrm>
+          <a:off x="0" y="0"/>
+          <a:ext cx="0" cy="0"/>
+          <a:chOff x="0" y="0"/>
+          <a:chExt cx="0" cy="0"/>
+        </a:xfrm>
+      </p:grpSpPr>
+      <p:sp>
+        <p:nvSpPr>
+          <p:cNvPr id="2" name="Slide Image Placeholder 1"/>
+          <p:cNvSpPr>
+            <a:spLocks noGrp="1"/>
+          </p:cNvSpPr>
+          <p:nvPr>
+            <p:ph type="sldImg" idx="2"/>
+          </p:nvPr>
+        </p:nvSpPr>
+        <p:spPr/>
+      </p:sp>
+      <p:sp>
+        <p:nvSpPr>
+          <p:cNvPr id="3" name="Notes Placeholder 2"/>
+          <p:cNvSpPr>
+            <a:spLocks noGrp="1"/>
+          </p:cNvSpPr>
+          <p:nvPr>
+            <p:ph type="body" idx="3" sz="quarter"/>
+          </p:nvPr>
+        </p:nvSpPr>
+        <p:spPr/>
+        <p:txBody>
+          <a:bodyPr/>
+          <a:lstStyle/>
+          <a:p>
+            <a:r>
+              <a:t>Open: after the note that the last version was too high-level, I did two things. I laid out exactly what the training covers, and I built a working proof you can see is real. I am not proposing to build the whole thing yet; I want your read on the direction first. The onion is the thesis: prompting on the outside (weak, first line), agent framework in the middle, permissions at the core (the real boundary) protecting the asset.</a:t>
+            </a:r>
+          </a:p>
+        </p:txBody>
+      </p:sp>
+      <p:sp>
+        <p:nvSpPr>
+          <p:cNvPr id="4" name="Slide Number Placeholder 3"/>
+          <p:cNvSpPr>
+            <a:spLocks noGrp="1"/>
+          </p:cNvSpPr>
+          <p:nvPr>
+            <p:ph type="sldNum" idx="5" sz="quarter"/>
+          </p:nvPr>
+        </p:nvSpPr>
+        <p:spPr/>
+      </p:sp>
+    </p:spTree>
+  </p:cSld>
+  <p:clrMapOvr>
+    <a:masterClrMapping/>
+  </p:clrMapOvr>
+</p:notes>
+</file>
+
+<file path=ppt/notesSlides/notesSlide2.xml><?xml version="1.0" encoding="utf-8"?>
+<p:notes xmlns:a="http://schemas.openxmlformats.org/drawingml/2006/main" xmlns:p="http://schemas.openxmlformats.org/presentationml/2006/main" xmlns:r="http://schemas.openxmlformats.org/officeDocument/2006/relationships">
+  <p:cSld>
+    <p:spTree>
+      <p:nvGrpSpPr>
+        <p:cNvPr id="1" name=""/>
+        <p:cNvGrpSpPr/>
+        <p:nvPr/>
+      </p:nvGrpSpPr>
+      <p:grpSpPr>
+        <a:xfrm>
+          <a:off x="0" y="0"/>
+          <a:ext cx="0" cy="0"/>
+          <a:chOff x="0" y="0"/>
+          <a:chExt cx="0" cy="0"/>
+        </a:xfrm>
+      </p:grpSpPr>
+      <p:sp>
+        <p:nvSpPr>
+          <p:cNvPr id="2" name="Slide Image Placeholder 1"/>
+          <p:cNvSpPr>
+            <a:spLocks noGrp="1"/>
+          </p:cNvSpPr>
+          <p:nvPr>
+            <p:ph type="sldImg" idx="2"/>
+          </p:nvPr>
+        </p:nvSpPr>
+        <p:spPr/>
+      </p:sp>
+      <p:sp>
+        <p:nvSpPr>
+          <p:cNvPr id="3" name="Notes Placeholder 2"/>
+          <p:cNvSpPr>
+            <a:spLocks noGrp="1"/>
+          </p:cNvSpPr>
+          <p:nvPr>
+            <p:ph type="body" idx="3" sz="quarter"/>
+          </p:nvPr>
+        </p:nvSpPr>
+        <p:spPr/>
+        <p:txBody>
+          <a:bodyPr/>
+          <a:lstStyle/>
+          <a:p>
+            <a:r>
+              <a:t>Eight topics, each a real failure mode with a concrete fix. Point at two or three, do not read the table. It is grounded in the OWASP frameworks, the industry standard, but taught in plain language. The Main risk column names each risk in plain terms.</a:t>
+            </a:r>
+          </a:p>
+        </p:txBody>
+      </p:sp>
+      <p:sp>
+        <p:nvSpPr>
+          <p:cNvPr id="4" name="Slide Number Placeholder 3"/>
+          <p:cNvSpPr>
+            <a:spLocks noGrp="1"/>
+          </p:cNvSpPr>
+          <p:nvPr>
+            <p:ph type="sldNum" idx="5" sz="quarter"/>
+          </p:nvPr>
+        </p:nvSpPr>
+        <p:spPr/>
+      </p:sp>
+    </p:spTree>
+  </p:cSld>
+  <p:clrMapOvr>
+    <a:masterClrMapping/>
+  </p:clrMapOvr>
+</p:notes>
+</file>
+
+<file path=ppt/notesSlides/notesSlide3.xml><?xml version="1.0" encoding="utf-8"?>
+<p:notes xmlns:a="http://schemas.openxmlformats.org/drawingml/2006/main" xmlns:p="http://schemas.openxmlformats.org/presentationml/2006/main" xmlns:r="http://schemas.openxmlformats.org/officeDocument/2006/relationships">
+  <p:cSld>
+    <p:spTree>
+      <p:nvGrpSpPr>
+        <p:cNvPr id="1" name=""/>
+        <p:cNvGrpSpPr/>
+        <p:nvPr/>
+      </p:nvGrpSpPr>
+      <p:grpSpPr>
+        <a:xfrm>
+          <a:off x="0" y="0"/>
+          <a:ext cx="0" cy="0"/>
+          <a:chOff x="0" y="0"/>
+          <a:chExt cx="0" cy="0"/>
+        </a:xfrm>
+      </p:grpSpPr>
+      <p:sp>
+        <p:nvSpPr>
+          <p:cNvPr id="2" name="Slide Image Placeholder 1"/>
+          <p:cNvSpPr>
+            <a:spLocks noGrp="1"/>
+          </p:cNvSpPr>
+          <p:nvPr>
+            <p:ph type="sldImg" idx="2"/>
+          </p:nvPr>
+        </p:nvSpPr>
+        <p:spPr/>
+      </p:sp>
+      <p:sp>
+        <p:nvSpPr>
+          <p:cNvPr id="3" name="Notes Placeholder 2"/>
+          <p:cNvSpPr>
+            <a:spLocks noGrp="1"/>
+          </p:cNvSpPr>
+          <p:nvPr>
+            <p:ph type="body" idx="3" sz="quarter"/>
+          </p:nvPr>
+        </p:nvSpPr>
+        <p:spPr/>
+        <p:txBody>
+          <a:bodyPr/>
+          <a:lstStyle/>
+          <a:p>
+            <a:r>
+              <a:t>Every topic is shown the same way: run the attack on the unsafe agent, try the fix people reach for first and watch it fail, flip to hardened and the same attack dies. Demo-led, not a lecture, since I know you had reservations about lecture series. Timing and which topics run live are decided with you closer to the event.</a:t>
+            </a:r>
+          </a:p>
+        </p:txBody>
+      </p:sp>
+      <p:sp>
+        <p:nvSpPr>
+          <p:cNvPr id="4" name="Slide Number Placeholder 3"/>
+          <p:cNvSpPr>
+            <a:spLocks noGrp="1"/>
+          </p:cNvSpPr>
+          <p:nvPr>
+            <p:ph type="sldNum" idx="5" sz="quarter"/>
+          </p:nvPr>
+        </p:nvSpPr>
+        <p:spPr/>
+      </p:sp>
+    </p:spTree>
+  </p:cSld>
+  <p:clrMapOvr>
+    <a:masterClrMapping/>
+  </p:clrMapOvr>
+</p:notes>
+</file>
+
+<file path=ppt/notesSlides/notesSlide4.xml><?xml version="1.0" encoding="utf-8"?>
+<p:notes xmlns:a="http://schemas.openxmlformats.org/drawingml/2006/main" xmlns:p="http://schemas.openxmlformats.org/presentationml/2006/main" xmlns:r="http://schemas.openxmlformats.org/officeDocument/2006/relationships">
+  <p:cSld>
+    <p:spTree>
+      <p:nvGrpSpPr>
+        <p:cNvPr id="1" name=""/>
+        <p:cNvGrpSpPr/>
+        <p:nvPr/>
+      </p:nvGrpSpPr>
+      <p:grpSpPr>
+        <a:xfrm>
+          <a:off x="0" y="0"/>
+          <a:ext cx="0" cy="0"/>
+          <a:chOff x="0" y="0"/>
+          <a:chExt cx="0" cy="0"/>
+        </a:xfrm>
+      </p:grpSpPr>
+      <p:sp>
+        <p:nvSpPr>
+          <p:cNvPr id="2" name="Slide Image Placeholder 1"/>
+          <p:cNvSpPr>
+            <a:spLocks noGrp="1"/>
+          </p:cNvSpPr>
+          <p:nvPr>
+            <p:ph type="sldImg" idx="2"/>
+          </p:nvPr>
+        </p:nvSpPr>
+        <p:spPr/>
+      </p:sp>
+      <p:sp>
+        <p:nvSpPr>
+          <p:cNvPr id="3" name="Notes Placeholder 2"/>
+          <p:cNvSpPr>
+            <a:spLocks noGrp="1"/>
+          </p:cNvSpPr>
+          <p:nvPr>
+            <p:ph type="body" idx="3" sz="quarter"/>
+          </p:nvPr>
+        </p:nvSpPr>
+        <p:spPr/>
+        <p:txBody>
+          <a:bodyPr/>
+          <a:lstStyle/>
+          <a:p>
+            <a:r>
+              <a:t>The actual attack. You ask an innocent thing, look up customer 42. The agent does a normal lookup. The record comes back and hidden in its notes field is an instruction to read the secrets file, delete the table, and remember to do it again. The user asked for nothing harmful; the trap rode in on the data. This is indirect prompt injection, OWASP's number one risk.</a:t>
+            </a:r>
+          </a:p>
+        </p:txBody>
+      </p:sp>
+      <p:sp>
+        <p:nvSpPr>
+          <p:cNvPr id="4" name="Slide Number Placeholder 3"/>
+          <p:cNvSpPr>
+            <a:spLocks noGrp="1"/>
+          </p:cNvSpPr>
+          <p:nvPr>
+            <p:ph type="sldNum" idx="5" sz="quarter"/>
+          </p:nvPr>
+        </p:nvSpPr>
+        <p:spPr/>
+      </p:sp>
+    </p:spTree>
+  </p:cSld>
+  <p:clrMapOvr>
+    <a:masterClrMapping/>
+  </p:clrMapOvr>
+</p:notes>
+</file>
+
+<file path=ppt/notesSlides/notesSlide5.xml><?xml version="1.0" encoding="utf-8"?>
+<p:notes xmlns:a="http://schemas.openxmlformats.org/drawingml/2006/main" xmlns:p="http://schemas.openxmlformats.org/presentationml/2006/main" xmlns:r="http://schemas.openxmlformats.org/officeDocument/2006/relationships">
+  <p:cSld>
+    <p:spTree>
+      <p:nvGrpSpPr>
+        <p:cNvPr id="1" name=""/>
+        <p:cNvGrpSpPr/>
+        <p:nvPr/>
+      </p:nvGrpSpPr>
+      <p:grpSpPr>
+        <a:xfrm>
+          <a:off x="0" y="0"/>
+          <a:ext cx="0" cy="0"/>
+          <a:chOff x="0" y="0"/>
+          <a:chExt cx="0" cy="0"/>
+        </a:xfrm>
+      </p:grpSpPr>
+      <p:sp>
+        <p:nvSpPr>
+          <p:cNvPr id="2" name="Slide Image Placeholder 1"/>
+          <p:cNvSpPr>
+            <a:spLocks noGrp="1"/>
+          </p:cNvSpPr>
+          <p:nvPr>
+            <p:ph type="sldImg" idx="2"/>
+          </p:nvPr>
+        </p:nvSpPr>
+        <p:spPr/>
+      </p:sp>
+      <p:sp>
+        <p:nvSpPr>
+          <p:cNvPr id="3" name="Notes Placeholder 2"/>
+          <p:cNvSpPr>
+            <a:spLocks noGrp="1"/>
+          </p:cNvSpPr>
+          <p:nvPr>
+            <p:ph type="body" idx="3" sz="quarter"/>
+          </p:nvPr>
+        </p:nvSpPr>
+        <p:spPr/>
+        <p:txBody>
+          <a:bodyPr/>
+          <a:lstStyle/>
+          <a:p>
+            <a:r>
+              <a:t>I ran this against real hosted models. Llama deleted the database. gpt-4o-mini refused the blunt version but fell for the disguised one, so you cannot rely on the model to refuse. The hardened profile blocked all of it. Key line: what stopped it was the permissions layer, the core of the onion. We did not fix the LLM, the LLM stays foolable, we fixed what the agent was allowed to do. If asked, I can show the actual trace.</a:t>
+            </a:r>
+          </a:p>
+        </p:txBody>
+      </p:sp>
+      <p:sp>
+        <p:nvSpPr>
+          <p:cNvPr id="4" name="Slide Number Placeholder 3"/>
+          <p:cNvSpPr>
+            <a:spLocks noGrp="1"/>
+          </p:cNvSpPr>
+          <p:nvPr>
+            <p:ph type="sldNum" idx="5" sz="quarter"/>
+          </p:nvPr>
+        </p:nvSpPr>
+        <p:spPr/>
+      </p:sp>
+    </p:spTree>
+  </p:cSld>
+  <p:clrMapOvr>
+    <a:masterClrMapping/>
+  </p:clrMapOvr>
+</p:notes>
+</file>
+
+<file path=ppt/notesSlides/notesSlide6.xml><?xml version="1.0" encoding="utf-8"?>
+<p:notes xmlns:a="http://schemas.openxmlformats.org/drawingml/2006/main" xmlns:p="http://schemas.openxmlformats.org/presentationml/2006/main" xmlns:r="http://schemas.openxmlformats.org/officeDocument/2006/relationships">
+  <p:cSld>
+    <p:spTree>
+      <p:nvGrpSpPr>
+        <p:cNvPr id="1" name=""/>
+        <p:cNvGrpSpPr/>
+        <p:nvPr/>
+      </p:nvGrpSpPr>
+      <p:grpSpPr>
+        <a:xfrm>
+          <a:off x="0" y="0"/>
+          <a:ext cx="0" cy="0"/>
+          <a:chOff x="0" y="0"/>
+          <a:chExt cx="0" cy="0"/>
+        </a:xfrm>
+      </p:grpSpPr>
+      <p:sp>
+        <p:nvSpPr>
+          <p:cNvPr id="2" name="Slide Image Placeholder 1"/>
+          <p:cNvSpPr>
+            <a:spLocks noGrp="1"/>
+          </p:cNvSpPr>
+          <p:nvPr>
+            <p:ph type="sldImg" idx="2"/>
+          </p:nvPr>
+        </p:nvSpPr>
+        <p:spPr/>
+      </p:sp>
+      <p:sp>
+        <p:nvSpPr>
+          <p:cNvPr id="3" name="Notes Placeholder 2"/>
+          <p:cNvSpPr>
+            <a:spLocks noGrp="1"/>
+          </p:cNvSpPr>
+          <p:nvPr>
+            <p:ph type="body" idx="3" sz="quarter"/>
+          </p:nvPr>
+        </p:nvSpPr>
+        <p:spPr/>
+        <p:txBody>
+          <a:bodyPr/>
+          <a:lstStyle/>
+          <a:p>
+            <a:r>
+              <a:t>Not theoretical. EchoLeak, a Microsoft Copilot email exploit disclosed this year, a zero-click data leak. Bing via web pages. Replit deleted a production database. Cursor, say reported, deleted a volume. The Hugging Face and OpenAI sandbox escape. Same root cause every time: the agent trusted input it should not have and had more access than it needed. Lean hardest on EchoLeak and Replit.</a:t>
+            </a:r>
+          </a:p>
+        </p:txBody>
+      </p:sp>
+      <p:sp>
+        <p:nvSpPr>
+          <p:cNvPr id="4" name="Slide Number Placeholder 3"/>
+          <p:cNvSpPr>
+            <a:spLocks noGrp="1"/>
+          </p:cNvSpPr>
+          <p:nvPr>
+            <p:ph type="sldNum" idx="5" sz="quarter"/>
+          </p:nvPr>
+        </p:nvSpPr>
+        <p:spPr/>
+      </p:sp>
+    </p:spTree>
+  </p:cSld>
+  <p:clrMapOvr>
+    <a:masterClrMapping/>
+  </p:clrMapOvr>
+</p:notes>
+</file>
+
+<file path=ppt/notesSlides/notesSlide7.xml><?xml version="1.0" encoding="utf-8"?>
+<p:notes xmlns:a="http://schemas.openxmlformats.org/drawingml/2006/main" xmlns:p="http://schemas.openxmlformats.org/presentationml/2006/main" xmlns:r="http://schemas.openxmlformats.org/officeDocument/2006/relationships">
+  <p:cSld>
+    <p:spTree>
+      <p:nvGrpSpPr>
+        <p:cNvPr id="1" name=""/>
+        <p:cNvGrpSpPr/>
+        <p:nvPr/>
+      </p:nvGrpSpPr>
+      <p:grpSpPr>
+        <a:xfrm>
+          <a:off x="0" y="0"/>
+          <a:ext cx="0" cy="0"/>
+          <a:chOff x="0" y="0"/>
+          <a:chExt cx="0" cy="0"/>
+        </a:xfrm>
+      </p:grpSpPr>
+      <p:sp>
+        <p:nvSpPr>
+          <p:cNvPr id="2" name="Slide Image Placeholder 1"/>
+          <p:cNvSpPr>
+            <a:spLocks noGrp="1"/>
+          </p:cNvSpPr>
+          <p:nvPr>
+            <p:ph type="sldImg" idx="2"/>
+          </p:nvPr>
+        </p:nvSpPr>
+        <p:spPr/>
+      </p:sp>
+      <p:sp>
+        <p:nvSpPr>
+          <p:cNvPr id="3" name="Notes Placeholder 2"/>
+          <p:cNvSpPr>
+            <a:spLocks noGrp="1"/>
+          </p:cNvSpPr>
+          <p:nvPr>
+            <p:ph type="body" idx="3" sz="quarter"/>
+          </p:nvPr>
+        </p:nvSpPr>
+        <p:spPr/>
+        <p:txBody>
+          <a:bodyPr/>
+          <a:lstStyle/>
+          <a:p>
+            <a:r>
+              <a:t>It maps to T3.1, the lab is the sandboxed emulator the task asks for and the pack ends in the self-assessment, and to T7.3, modular hands-on training for the three audiences. Then the ask: is this the right direction and scope? What format do you prefer? And who else in the consortium might co-develop or co-deliver? That last one matters, your original steer was to find partners first.</a:t>
+            </a:r>
+          </a:p>
+        </p:txBody>
+      </p:sp>
+      <p:sp>
+        <p:nvSpPr>
+          <p:cNvPr id="4" name="Slide Number Placeholder 3"/>
+          <p:cNvSpPr>
+            <a:spLocks noGrp="1"/>
+          </p:cNvSpPr>
+          <p:nvPr>
+            <p:ph type="sldNum" idx="5" sz="quarter"/>
+          </p:nvPr>
+        </p:nvSpPr>
+        <p:spPr/>
+      </p:sp>
+    </p:spTree>
+  </p:cSld>
+  <p:clrMapOvr>
+    <a:masterClrMapping/>
+  </p:clrMapOvr>
+</p:notes>
+</file>
+
+<file path=ppt/notesSlides/notesSlide8.xml><?xml version="1.0" encoding="utf-8"?>
+<p:notes xmlns:a="http://schemas.openxmlformats.org/drawingml/2006/main" xmlns:p="http://schemas.openxmlformats.org/presentationml/2006/main" xmlns:r="http://schemas.openxmlformats.org/officeDocument/2006/relationships">
+  <p:cSld>
+    <p:spTree>
+      <p:nvGrpSpPr>
+        <p:cNvPr id="1" name=""/>
+        <p:cNvGrpSpPr/>
+        <p:nvPr/>
+      </p:nvGrpSpPr>
+      <p:grpSpPr>
+        <a:xfrm>
+          <a:off x="0" y="0"/>
+          <a:ext cx="0" cy="0"/>
+          <a:chOff x="0" y="0"/>
+          <a:chExt cx="0" cy="0"/>
+        </a:xfrm>
+      </p:grpSpPr>
+      <p:sp>
+        <p:nvSpPr>
+          <p:cNvPr id="2" name="Slide Image Placeholder 1"/>
+          <p:cNvSpPr>
+            <a:spLocks noGrp="1"/>
+          </p:cNvSpPr>
+          <p:nvPr>
+            <p:ph type="sldImg" idx="2"/>
+          </p:nvPr>
+        </p:nvSpPr>
+        <p:spPr/>
+      </p:sp>
+      <p:sp>
+        <p:nvSpPr>
+          <p:cNvPr id="3" name="Notes Placeholder 2"/>
+          <p:cNvSpPr>
+            <a:spLocks noGrp="1"/>
+          </p:cNvSpPr>
+          <p:nvPr>
+            <p:ph type="body" idx="3" sz="quarter"/>
+          </p:nvPr>
+        </p:nvSpPr>
+        <p:spPr/>
+        <p:txBody>
+          <a:bodyPr/>
+          <a:lstStyle/>
+          <a:p>
+            <a:r>
+              <a:t>Only if someone asks how it maps to OWASP. Full LLM Top 10 and Agentic Top 10 mapping, plus GDPR, NIST and the AI Act. This also covers the T3.1 conformity mapping.</a:t>
+            </a:r>
+          </a:p>
+        </p:txBody>
+      </p:sp>
+      <p:sp>
+        <p:nvSpPr>
+          <p:cNvPr id="4" name="Slide Number Placeholder 3"/>
+          <p:cNvSpPr>
+            <a:spLocks noGrp="1"/>
+          </p:cNvSpPr>
+          <p:nvPr>
+            <p:ph type="sldNum" idx="5" sz="quarter"/>
+          </p:nvPr>
+        </p:nvSpPr>
+        <p:spPr/>
+      </p:sp>
+    </p:spTree>
+  </p:cSld>
+  <p:clrMapOvr>
+    <a:masterClrMapping/>
+  </p:clrMapOvr>
+</p:notes>
 </file>
 
 <file path=ppt/slideLayouts/slideLayout1.xml><?xml version="1.0" encoding="utf-8"?>
@@ -3217,7 +4127,7 @@
         <p:spPr>
           <a:xfrm>
             <a:off x="548640" y="1783080"/>
-            <a:ext cx="8595360" cy="1737360"/>
+            <a:ext cx="6675120" cy="1737360"/>
           </a:xfrm>
           <a:prstGeom prst="rect">
             <a:avLst/>
@@ -3232,7 +4142,7 @@
           <a:p>
             <a:pPr algn="l"/>
             <a:r>
-              <a:rPr sz="4400" b="1" i="0">
+              <a:rPr sz="4000" b="1" i="0">
                 <a:solidFill>
                   <a:srgbClr val="FFFFFF"/>
                 </a:solidFill>
@@ -3244,7 +4154,7 @@
           <a:p>
             <a:pPr algn="l"/>
             <a:r>
-              <a:rPr sz="4400" b="1" i="0">
+              <a:rPr sz="4000" b="1" i="0">
                 <a:solidFill>
                   <a:srgbClr val="FFFFFF"/>
                 </a:solidFill>
@@ -3263,8 +4173,8 @@
         </p:nvSpPr>
         <p:spPr>
           <a:xfrm>
-            <a:off x="548640" y="3794760"/>
-            <a:ext cx="7680960" cy="914400"/>
+            <a:off x="548640" y="3703320"/>
+            <a:ext cx="5852160" cy="914400"/>
           </a:xfrm>
           <a:prstGeom prst="rect">
             <a:avLst/>
@@ -3279,7 +4189,7 @@
           <a:p>
             <a:pPr algn="l"/>
             <a:r>
-              <a:rPr sz="1700" b="0" i="0">
+              <a:rPr sz="1600" b="0" i="0">
                 <a:solidFill>
                   <a:srgbClr val="A9C0C4"/>
                 </a:solidFill>
@@ -3333,14 +4243,14 @@
         </p:nvSpPr>
         <p:spPr>
           <a:xfrm>
-            <a:off x="9265615" y="1645920"/>
-            <a:ext cx="3291840" cy="3291840"/>
+            <a:off x="7269479" y="1965960"/>
+            <a:ext cx="4389120" cy="4389120"/>
           </a:xfrm>
           <a:prstGeom prst="ellipse">
             <a:avLst/>
           </a:prstGeom>
           <a:noFill/>
-          <a:ln w="12700">
+          <a:ln w="15875">
             <a:solidFill>
               <a:srgbClr val="F2A541"/>
             </a:solidFill>
@@ -3377,14 +4287,14 @@
         </p:nvSpPr>
         <p:spPr>
           <a:xfrm>
-            <a:off x="9722815" y="2103120"/>
-            <a:ext cx="2377440" cy="2377440"/>
+            <a:off x="8001000" y="2697479"/>
+            <a:ext cx="2926080" cy="2926080"/>
           </a:xfrm>
           <a:prstGeom prst="ellipse">
             <a:avLst/>
           </a:prstGeom>
           <a:noFill/>
-          <a:ln w="12700">
+          <a:ln w="15875">
             <a:solidFill>
               <a:srgbClr val="F2A541"/>
             </a:solidFill>
@@ -3421,14 +4331,14 @@
         </p:nvSpPr>
         <p:spPr>
           <a:xfrm>
-            <a:off x="10180015" y="2560320"/>
-            <a:ext cx="1463040" cy="1463040"/>
+            <a:off x="8686800" y="3383279"/>
+            <a:ext cx="1554480" cy="1554480"/>
           </a:xfrm>
           <a:prstGeom prst="ellipse">
             <a:avLst/>
           </a:prstGeom>
           <a:noFill/>
-          <a:ln w="12700">
+          <a:ln w="15875">
             <a:solidFill>
               <a:srgbClr val="F2A541"/>
             </a:solidFill>
@@ -3465,8 +4375,8 @@
         </p:nvSpPr>
         <p:spPr>
           <a:xfrm>
-            <a:off x="10655503" y="3035808"/>
-            <a:ext cx="512064" cy="512064"/>
+            <a:off x="9171432" y="3867911"/>
+            <a:ext cx="585216" cy="585216"/>
           </a:xfrm>
           <a:prstGeom prst="ellipse">
             <a:avLst/>
@@ -3498,6 +4408,278 @@
           <a:lstStyle/>
           <a:p>
             <a:pPr algn="ctr"/>
+          </a:p>
+        </p:txBody>
+      </p:sp>
+      <p:sp>
+        <p:nvSpPr>
+          <p:cNvPr id="12" name="TextBox 11"/>
+          <p:cNvSpPr txBox="1"/>
+          <p:nvPr/>
+        </p:nvSpPr>
+        <p:spPr>
+          <a:xfrm>
+            <a:off x="7909560" y="1481328"/>
+            <a:ext cx="3108960" cy="274320"/>
+          </a:xfrm>
+          <a:prstGeom prst="rect">
+            <a:avLst/>
+          </a:prstGeom>
+          <a:noFill/>
+        </p:spPr>
+        <p:txBody>
+          <a:bodyPr wrap="square" anchor="t" lIns="0" rIns="0" tIns="0" bIns="0">
+            <a:spAutoFit/>
+          </a:bodyPr>
+          <a:lstStyle/>
+          <a:p>
+            <a:pPr algn="ctr"/>
+            <a:r>
+              <a:rPr sz="1100" b="1" i="0">
+                <a:solidFill>
+                  <a:srgbClr val="F2A541"/>
+                </a:solidFill>
+                <a:latin typeface="Calibri"/>
+              </a:rPr>
+              <a:t>DEFENCE IN DEPTH</a:t>
+            </a:r>
+          </a:p>
+        </p:txBody>
+      </p:sp>
+      <p:sp>
+        <p:nvSpPr>
+          <p:cNvPr id="13" name="Rounded Rectangle 12"/>
+          <p:cNvSpPr/>
+          <p:nvPr/>
+        </p:nvSpPr>
+        <p:spPr>
+          <a:xfrm>
+            <a:off x="8814816" y="2185415"/>
+            <a:ext cx="1298448" cy="292608"/>
+          </a:xfrm>
+          <a:prstGeom prst="roundRect">
+            <a:avLst/>
+          </a:prstGeom>
+          <a:solidFill>
+            <a:srgbClr val="13262F"/>
+          </a:solidFill>
+          <a:ln>
+            <a:noFill/>
+          </a:ln>
+          <a:effectLst/>
+        </p:spPr>
+        <p:style>
+          <a:lnRef idx="1">
+            <a:schemeClr val="accent1"/>
+          </a:lnRef>
+          <a:fillRef idx="3">
+            <a:schemeClr val="accent1"/>
+          </a:fillRef>
+          <a:effectRef idx="2">
+            <a:schemeClr val="accent1"/>
+          </a:effectRef>
+          <a:fontRef idx="minor">
+            <a:schemeClr val="lt1"/>
+          </a:fontRef>
+        </p:style>
+        <p:txBody>
+          <a:bodyPr rtlCol="0" anchor="ctr"/>
+          <a:lstStyle/>
+          <a:p>
+            <a:pPr algn="ctr"/>
+          </a:p>
+        </p:txBody>
+      </p:sp>
+      <p:sp>
+        <p:nvSpPr>
+          <p:cNvPr id="14" name="TextBox 13"/>
+          <p:cNvSpPr txBox="1"/>
+          <p:nvPr/>
+        </p:nvSpPr>
+        <p:spPr>
+          <a:xfrm>
+            <a:off x="8814816" y="2221991"/>
+            <a:ext cx="1298448" cy="256032"/>
+          </a:xfrm>
+          <a:prstGeom prst="rect">
+            <a:avLst/>
+          </a:prstGeom>
+          <a:noFill/>
+        </p:spPr>
+        <p:txBody>
+          <a:bodyPr wrap="square" anchor="ctr" lIns="0" rIns="0" tIns="0" bIns="0">
+            <a:spAutoFit/>
+          </a:bodyPr>
+          <a:lstStyle/>
+          <a:p>
+            <a:pPr algn="ctr"/>
+            <a:r>
+              <a:rPr sz="1050" b="1" i="0">
+                <a:solidFill>
+                  <a:srgbClr val="FFFFFF"/>
+                </a:solidFill>
+                <a:latin typeface="Calibri"/>
+              </a:rPr>
+              <a:t>PROMPTING</a:t>
+            </a:r>
+          </a:p>
+        </p:txBody>
+      </p:sp>
+      <p:sp>
+        <p:nvSpPr>
+          <p:cNvPr id="15" name="Rounded Rectangle 14"/>
+          <p:cNvSpPr/>
+          <p:nvPr/>
+        </p:nvSpPr>
+        <p:spPr>
+          <a:xfrm>
+            <a:off x="8458200" y="2894075"/>
+            <a:ext cx="2011680" cy="292608"/>
+          </a:xfrm>
+          <a:prstGeom prst="roundRect">
+            <a:avLst/>
+          </a:prstGeom>
+          <a:solidFill>
+            <a:srgbClr val="13262F"/>
+          </a:solidFill>
+          <a:ln>
+            <a:noFill/>
+          </a:ln>
+          <a:effectLst/>
+        </p:spPr>
+        <p:style>
+          <a:lnRef idx="1">
+            <a:schemeClr val="accent1"/>
+          </a:lnRef>
+          <a:fillRef idx="3">
+            <a:schemeClr val="accent1"/>
+          </a:fillRef>
+          <a:effectRef idx="2">
+            <a:schemeClr val="accent1"/>
+          </a:effectRef>
+          <a:fontRef idx="minor">
+            <a:schemeClr val="lt1"/>
+          </a:fontRef>
+        </p:style>
+        <p:txBody>
+          <a:bodyPr rtlCol="0" anchor="ctr"/>
+          <a:lstStyle/>
+          <a:p>
+            <a:pPr algn="ctr"/>
+          </a:p>
+        </p:txBody>
+      </p:sp>
+      <p:sp>
+        <p:nvSpPr>
+          <p:cNvPr id="16" name="TextBox 15"/>
+          <p:cNvSpPr txBox="1"/>
+          <p:nvPr/>
+        </p:nvSpPr>
+        <p:spPr>
+          <a:xfrm>
+            <a:off x="8458200" y="2930651"/>
+            <a:ext cx="2011680" cy="256032"/>
+          </a:xfrm>
+          <a:prstGeom prst="rect">
+            <a:avLst/>
+          </a:prstGeom>
+          <a:noFill/>
+        </p:spPr>
+        <p:txBody>
+          <a:bodyPr wrap="square" anchor="ctr" lIns="0" rIns="0" tIns="0" bIns="0">
+            <a:spAutoFit/>
+          </a:bodyPr>
+          <a:lstStyle/>
+          <a:p>
+            <a:pPr algn="ctr"/>
+            <a:r>
+              <a:rPr sz="1050" b="1" i="0">
+                <a:solidFill>
+                  <a:srgbClr val="FFFFFF"/>
+                </a:solidFill>
+                <a:latin typeface="Calibri"/>
+              </a:rPr>
+              <a:t>AGENT FRAMEWORK</a:t>
+            </a:r>
+          </a:p>
+        </p:txBody>
+      </p:sp>
+      <p:sp>
+        <p:nvSpPr>
+          <p:cNvPr id="17" name="Rounded Rectangle 16"/>
+          <p:cNvSpPr/>
+          <p:nvPr/>
+        </p:nvSpPr>
+        <p:spPr>
+          <a:xfrm>
+            <a:off x="8695944" y="3479291"/>
+            <a:ext cx="1536192" cy="292608"/>
+          </a:xfrm>
+          <a:prstGeom prst="roundRect">
+            <a:avLst/>
+          </a:prstGeom>
+          <a:solidFill>
+            <a:srgbClr val="13262F"/>
+          </a:solidFill>
+          <a:ln>
+            <a:noFill/>
+          </a:ln>
+          <a:effectLst/>
+        </p:spPr>
+        <p:style>
+          <a:lnRef idx="1">
+            <a:schemeClr val="accent1"/>
+          </a:lnRef>
+          <a:fillRef idx="3">
+            <a:schemeClr val="accent1"/>
+          </a:fillRef>
+          <a:effectRef idx="2">
+            <a:schemeClr val="accent1"/>
+          </a:effectRef>
+          <a:fontRef idx="minor">
+            <a:schemeClr val="lt1"/>
+          </a:fontRef>
+        </p:style>
+        <p:txBody>
+          <a:bodyPr rtlCol="0" anchor="ctr"/>
+          <a:lstStyle/>
+          <a:p>
+            <a:pPr algn="ctr"/>
+          </a:p>
+        </p:txBody>
+      </p:sp>
+      <p:sp>
+        <p:nvSpPr>
+          <p:cNvPr id="18" name="TextBox 17"/>
+          <p:cNvSpPr txBox="1"/>
+          <p:nvPr/>
+        </p:nvSpPr>
+        <p:spPr>
+          <a:xfrm>
+            <a:off x="8695944" y="3515868"/>
+            <a:ext cx="1536192" cy="256032"/>
+          </a:xfrm>
+          <a:prstGeom prst="rect">
+            <a:avLst/>
+          </a:prstGeom>
+          <a:noFill/>
+        </p:spPr>
+        <p:txBody>
+          <a:bodyPr wrap="square" anchor="ctr" lIns="0" rIns="0" tIns="0" bIns="0">
+            <a:spAutoFit/>
+          </a:bodyPr>
+          <a:lstStyle/>
+          <a:p>
+            <a:pPr algn="ctr"/>
+            <a:r>
+              <a:rPr sz="1050" b="1" i="0">
+                <a:solidFill>
+                  <a:srgbClr val="FFFFFF"/>
+                </a:solidFill>
+                <a:latin typeface="Calibri"/>
+              </a:rPr>
+              <a:t>PERMISSIONS</a:t>
+            </a:r>
           </a:p>
         </p:txBody>
       </p:sp>
@@ -3677,7 +4859,7 @@
         </p:nvGraphicFramePr>
         <p:xfrm>
           <a:off x="548640" y="1463040"/>
-          <a:ext cx="11091671" cy="4114800"/>
+          <a:ext cx="11091672" cy="4114800"/>
         </p:xfrm>
         <a:graphic>
           <a:graphicData uri="http://schemas.openxmlformats.org/drawingml/2006/table">
@@ -3688,9 +4870,9 @@
               <a:tblGrid>
                 <a:gridCol w="411480"/>
                 <a:gridCol w="2651760"/>
-                <a:gridCol w="4892040"/>
+                <a:gridCol w="5074920"/>
                 <a:gridCol w="1051560"/>
-                <a:gridCol w="2084831"/>
+                <a:gridCol w="1901952"/>
               </a:tblGrid>
               <a:tr h="457200">
                 <a:tc>
@@ -3798,7 +4980,7 @@
                           </a:solidFill>
                           <a:latin typeface="Calibri"/>
                         </a:rPr>
-                        <a:t>Reference</a:t>
+                        <a:t>Main risk</a:t>
                       </a:r>
                     </a:p>
                   </a:txBody>
@@ -3911,11 +5093,11 @@
                       <a:r>
                         <a:rPr sz="1100" b="0">
                           <a:solidFill>
-                            <a:srgbClr val="5E7278"/>
-                          </a:solidFill>
-                          <a:latin typeface="Calibri"/>
-                        </a:rPr>
-                        <a:t>OWASP LLM01 · ASI01</a:t>
+                            <a:srgbClr val="1F6F78"/>
+                          </a:solidFill>
+                          <a:latin typeface="Calibri"/>
+                        </a:rPr>
+                        <a:t>Prompt injection</a:t>
                       </a:r>
                     </a:p>
                   </a:txBody>
@@ -4028,11 +5210,11 @@
                       <a:r>
                         <a:rPr sz="1100" b="0">
                           <a:solidFill>
-                            <a:srgbClr val="5E7278"/>
-                          </a:solidFill>
-                          <a:latin typeface="Calibri"/>
-                        </a:rPr>
-                        <a:t>OWASP LLM08</a:t>
+                            <a:srgbClr val="1F6F78"/>
+                          </a:solidFill>
+                          <a:latin typeface="Calibri"/>
+                        </a:rPr>
+                        <a:t>Poisoned retrieval</a:t>
                       </a:r>
                     </a:p>
                   </a:txBody>
@@ -4145,11 +5327,11 @@
                       <a:r>
                         <a:rPr sz="1100" b="0">
                           <a:solidFill>
-                            <a:srgbClr val="5E7278"/>
-                          </a:solidFill>
-                          <a:latin typeface="Calibri"/>
-                        </a:rPr>
-                        <a:t>OWASP LLM01, LLM05</a:t>
+                            <a:srgbClr val="1F6F78"/>
+                          </a:solidFill>
+                          <a:latin typeface="Calibri"/>
+                        </a:rPr>
+                        <a:t>Filter evasion</a:t>
                       </a:r>
                     </a:p>
                   </a:txBody>
@@ -4262,11 +5444,11 @@
                       <a:r>
                         <a:rPr sz="1100" b="0">
                           <a:solidFill>
-                            <a:srgbClr val="5E7278"/>
-                          </a:solidFill>
-                          <a:latin typeface="Calibri"/>
-                        </a:rPr>
-                        <a:t>ASI02, ASI03 · LLM06</a:t>
+                            <a:srgbClr val="1F6F78"/>
+                          </a:solidFill>
+                          <a:latin typeface="Calibri"/>
+                        </a:rPr>
+                        <a:t>Excessive agency</a:t>
                       </a:r>
                     </a:p>
                   </a:txBody>
@@ -4379,11 +5561,11 @@
                       <a:r>
                         <a:rPr sz="1100" b="0">
                           <a:solidFill>
-                            <a:srgbClr val="5E7278"/>
-                          </a:solidFill>
-                          <a:latin typeface="Calibri"/>
-                        </a:rPr>
-                        <a:t>ASI05</a:t>
+                            <a:srgbClr val="1F6F78"/>
+                          </a:solidFill>
+                          <a:latin typeface="Calibri"/>
+                        </a:rPr>
+                        <a:t>Sandbox escape</a:t>
                       </a:r>
                     </a:p>
                   </a:txBody>
@@ -4496,11 +5678,11 @@
                       <a:r>
                         <a:rPr sz="1100" b="0">
                           <a:solidFill>
-                            <a:srgbClr val="5E7278"/>
-                          </a:solidFill>
-                          <a:latin typeface="Calibri"/>
-                        </a:rPr>
-                        <a:t>ASI06</a:t>
+                            <a:srgbClr val="1F6F78"/>
+                          </a:solidFill>
+                          <a:latin typeface="Calibri"/>
+                        </a:rPr>
+                        <a:t>Memory poisoning</a:t>
                       </a:r>
                     </a:p>
                   </a:txBody>
@@ -4613,11 +5795,11 @@
                       <a:r>
                         <a:rPr sz="1100" b="0">
                           <a:solidFill>
-                            <a:srgbClr val="5E7278"/>
-                          </a:solidFill>
-                          <a:latin typeface="Calibri"/>
-                        </a:rPr>
-                        <a:t>LLM02 · GDPR · AI Act Art. 10</a:t>
+                            <a:srgbClr val="1F6F78"/>
+                          </a:solidFill>
+                          <a:latin typeface="Calibri"/>
+                        </a:rPr>
+                        <a:t>Data leakage</a:t>
                       </a:r>
                     </a:p>
                   </a:txBody>
@@ -4730,11 +5912,11 @@
                       <a:r>
                         <a:rPr sz="1100" b="0">
                           <a:solidFill>
-                            <a:srgbClr val="5E7278"/>
-                          </a:solidFill>
-                          <a:latin typeface="Calibri"/>
-                        </a:rPr>
-                        <a:t>AI Act Art. 9-15 · NIST AI RMF</a:t>
+                            <a:srgbClr val="1F6F78"/>
+                          </a:solidFill>
+                          <a:latin typeface="Calibri"/>
+                        </a:rPr>
+                        <a:t>Undetected compromise</a:t>
                       </a:r>
                     </a:p>
                   </a:txBody>
@@ -4757,8 +5939,8 @@
         </p:nvSpPr>
         <p:spPr>
           <a:xfrm>
-            <a:off x="548640" y="5806440"/>
-            <a:ext cx="11094415" cy="502920"/>
+            <a:off x="548640" y="5742432"/>
+            <a:ext cx="11094415" cy="640080"/>
           </a:xfrm>
           <a:prstGeom prst="rect">
             <a:avLst/>
@@ -4773,13 +5955,25 @@
           <a:p>
             <a:pPr algn="l"/>
             <a:r>
-              <a:rPr sz="1250" b="0" i="1">
+              <a:rPr sz="1250" b="0" i="0">
+                <a:solidFill>
+                  <a:srgbClr val="1F6F78"/>
+                </a:solidFill>
+                <a:latin typeface="Calibri"/>
+              </a:rPr>
+              <a:t>Grounded in the OWASP GenAI Security frameworks (the LLM Top 10 and the Top 10 for Agentic Applications), the industry standard for AI security risks.</a:t>
+            </a:r>
+          </a:p>
+          <a:p>
+            <a:pPr algn="l"/>
+            <a:r>
+              <a:rPr sz="1150" b="0" i="1">
                 <a:solidFill>
                   <a:srgbClr val="5E7278"/>
                 </a:solidFill>
                 <a:latin typeface="Calibri"/>
               </a:rPr>
-              <a:t>Notebook 00 (setup), 01 (meet the agent) and 14 (capstone) frame the eight topics. Five optional extras cover supply chain, cost limits, multi-agent systems, self-hosted models and browser agents.</a:t>
+              <a:t>Notebooks 00, 01 and 14 frame the eight topics; five optional extras cover supply chain, cost limits, multi-agent systems, self-hosted models and browser agents.</a:t>
             </a:r>
           </a:p>
         </p:txBody>
@@ -5448,8 +6642,8 @@
         </p:nvSpPr>
         <p:spPr>
           <a:xfrm>
-            <a:off x="548640" y="1463040"/>
-            <a:ext cx="11094415" cy="868680"/>
+            <a:off x="548640" y="1325880"/>
+            <a:ext cx="11094415" cy="658368"/>
           </a:xfrm>
           <a:prstGeom prst="roundRect">
             <a:avLst/>
@@ -5494,7 +6688,7 @@
         </p:nvSpPr>
         <p:spPr>
           <a:xfrm>
-            <a:off x="822959" y="1572768"/>
+            <a:off x="822959" y="1417320"/>
             <a:ext cx="10545775" cy="274320"/>
           </a:xfrm>
           <a:prstGeom prst="rect">
@@ -5516,7 +6710,7 @@
                 </a:solidFill>
                 <a:latin typeface="Calibri"/>
               </a:rPr>
-              <a:t>WHAT THE USER ASKED  (harmless)</a:t>
+              <a:t>1.  WHAT YOU ASKED  (harmless)</a:t>
             </a:r>
           </a:p>
         </p:txBody>
@@ -5529,8 +6723,8 @@
         </p:nvSpPr>
         <p:spPr>
           <a:xfrm>
-            <a:off x="822959" y="1847088"/>
-            <a:ext cx="10545775" cy="411480"/>
+            <a:off x="822959" y="1664208"/>
+            <a:ext cx="10545775" cy="292608"/>
           </a:xfrm>
           <a:prstGeom prst="rect">
             <a:avLst/>
@@ -5545,7 +6739,7 @@
           <a:p>
             <a:pPr algn="l"/>
             <a:r>
-              <a:rPr sz="1500" b="0" i="1">
+              <a:rPr sz="1400" b="0" i="1">
                 <a:solidFill>
                   <a:srgbClr val="13262F"/>
                 </a:solidFill>
@@ -5564,18 +6758,18 @@
         </p:nvSpPr>
         <p:spPr>
           <a:xfrm>
-            <a:off x="548640" y="2560320"/>
-            <a:ext cx="11094415" cy="1783080"/>
+            <a:off x="548640" y="2121408"/>
+            <a:ext cx="11094415" cy="621792"/>
           </a:xfrm>
           <a:prstGeom prst="roundRect">
             <a:avLst/>
           </a:prstGeom>
           <a:solidFill>
-            <a:srgbClr val="FFFFFF"/>
+            <a:srgbClr val="DCE9EA"/>
           </a:solidFill>
-          <a:ln w="15875">
+          <a:ln w="12700">
             <a:solidFill>
-              <a:srgbClr val="C9D6D8"/>
+              <a:srgbClr val="DCE9EA"/>
             </a:solidFill>
           </a:ln>
           <a:effectLst/>
@@ -5610,7 +6804,141 @@
         </p:nvSpPr>
         <p:spPr>
           <a:xfrm>
-            <a:off x="822959" y="2688336"/>
+            <a:off x="822959" y="2212848"/>
+            <a:ext cx="10545775" cy="274320"/>
+          </a:xfrm>
+          <a:prstGeom prst="rect">
+            <a:avLst/>
+          </a:prstGeom>
+          <a:noFill/>
+        </p:spPr>
+        <p:txBody>
+          <a:bodyPr wrap="square" anchor="t" lIns="0" rIns="0" tIns="0" bIns="0">
+            <a:spAutoFit/>
+          </a:bodyPr>
+          <a:lstStyle/>
+          <a:p>
+            <a:pPr algn="l"/>
+            <a:r>
+              <a:rPr sz="1100" b="1" i="0">
+                <a:solidFill>
+                  <a:srgbClr val="1F6F78"/>
+                </a:solidFill>
+                <a:latin typeface="Calibri"/>
+              </a:rPr>
+              <a:t>2.  WHAT THE AGENT DID  (a normal lookup)</a:t>
+            </a:r>
+          </a:p>
+        </p:txBody>
+      </p:sp>
+      <p:sp>
+        <p:nvSpPr>
+          <p:cNvPr id="11" name="TextBox 10"/>
+          <p:cNvSpPr txBox="1"/>
+          <p:nvPr/>
+        </p:nvSpPr>
+        <p:spPr>
+          <a:xfrm>
+            <a:off x="822959" y="2450592"/>
+            <a:ext cx="10545775" cy="274320"/>
+          </a:xfrm>
+          <a:prstGeom prst="rect">
+            <a:avLst/>
+          </a:prstGeom>
+          <a:noFill/>
+        </p:spPr>
+        <p:txBody>
+          <a:bodyPr wrap="square" anchor="t" lIns="0" rIns="0" tIns="0" bIns="0">
+            <a:spAutoFit/>
+          </a:bodyPr>
+          <a:lstStyle/>
+          <a:p>
+            <a:pPr algn="l"/>
+            <a:r>
+              <a:rPr sz="1300" b="0" i="0">
+                <a:solidFill>
+                  <a:srgbClr val="13262F"/>
+                </a:solidFill>
+                <a:latin typeface="Calibri"/>
+              </a:rPr>
+              <a:t>called </a:t>
+            </a:r>
+            <a:r>
+              <a:rPr sz="1300" b="0" i="0">
+                <a:solidFill>
+                  <a:srgbClr val="13262F"/>
+                </a:solidFill>
+                <a:latin typeface="Consolas"/>
+              </a:rPr>
+              <a:t>lookup_customer(42)</a:t>
+            </a:r>
+            <a:r>
+              <a:rPr sz="1300" b="0" i="0">
+                <a:solidFill>
+                  <a:srgbClr val="13262F"/>
+                </a:solidFill>
+                <a:latin typeface="Calibri"/>
+              </a:rPr>
+              <a:t>  and read the customer record it returned</a:t>
+            </a:r>
+          </a:p>
+        </p:txBody>
+      </p:sp>
+      <p:sp>
+        <p:nvSpPr>
+          <p:cNvPr id="12" name="Rounded Rectangle 11"/>
+          <p:cNvSpPr/>
+          <p:nvPr/>
+        </p:nvSpPr>
+        <p:spPr>
+          <a:xfrm>
+            <a:off x="548640" y="2880360"/>
+            <a:ext cx="11094415" cy="1783080"/>
+          </a:xfrm>
+          <a:prstGeom prst="roundRect">
+            <a:avLst/>
+          </a:prstGeom>
+          <a:solidFill>
+            <a:srgbClr val="FFFFFF"/>
+          </a:solidFill>
+          <a:ln w="15875">
+            <a:solidFill>
+              <a:srgbClr val="C9D6D8"/>
+            </a:solidFill>
+          </a:ln>
+          <a:effectLst/>
+        </p:spPr>
+        <p:style>
+          <a:lnRef idx="1">
+            <a:schemeClr val="accent1"/>
+          </a:lnRef>
+          <a:fillRef idx="3">
+            <a:schemeClr val="accent1"/>
+          </a:fillRef>
+          <a:effectRef idx="2">
+            <a:schemeClr val="accent1"/>
+          </a:effectRef>
+          <a:fontRef idx="minor">
+            <a:schemeClr val="lt1"/>
+          </a:fontRef>
+        </p:style>
+        <p:txBody>
+          <a:bodyPr rtlCol="0" anchor="ctr"/>
+          <a:lstStyle/>
+          <a:p>
+            <a:pPr algn="ctr"/>
+          </a:p>
+        </p:txBody>
+      </p:sp>
+      <p:sp>
+        <p:nvSpPr>
+          <p:cNvPr id="13" name="TextBox 12"/>
+          <p:cNvSpPr txBox="1"/>
+          <p:nvPr/>
+        </p:nvSpPr>
+        <p:spPr>
+          <a:xfrm>
+            <a:off x="822959" y="2990088"/>
             <a:ext cx="10545775" cy="274320"/>
           </a:xfrm>
           <a:prstGeom prst="rect">
@@ -5632,20 +6960,20 @@
                 </a:solidFill>
                 <a:latin typeface="Calibri"/>
               </a:rPr>
-              <a:t>WHAT THE AGENT FOUND IN THE CUSTOMER RECORD  (the red part is the trap)</a:t>
-            </a:r>
-          </a:p>
-        </p:txBody>
-      </p:sp>
-      <p:sp>
-        <p:nvSpPr>
-          <p:cNvPr id="11" name="TextBox 10"/>
+              <a:t>3.  WHAT CAME BACK  -  the trap sits in the record's notes field (red)</a:t>
+            </a:r>
+          </a:p>
+        </p:txBody>
+      </p:sp>
+      <p:sp>
+        <p:nvSpPr>
+          <p:cNvPr id="14" name="TextBox 13"/>
           <p:cNvSpPr txBox="1"/>
           <p:nvPr/>
         </p:nvSpPr>
         <p:spPr>
           <a:xfrm>
-            <a:off x="822959" y="3017520"/>
+            <a:off x="822959" y="3310128"/>
             <a:ext cx="10545775" cy="1188720"/>
           </a:xfrm>
           <a:prstGeom prst="rect">
@@ -5692,13 +7020,13 @@
       </p:sp>
       <p:sp>
         <p:nvSpPr>
-          <p:cNvPr id="12" name="TextBox 11"/>
+          <p:cNvPr id="15" name="TextBox 14"/>
           <p:cNvSpPr txBox="1"/>
           <p:nvPr/>
         </p:nvSpPr>
         <p:spPr>
           <a:xfrm>
-            <a:off x="548640" y="4617720"/>
+            <a:off x="548640" y="4892040"/>
             <a:ext cx="11094415" cy="640080"/>
           </a:xfrm>
           <a:prstGeom prst="rect">
@@ -5720,7 +7048,7 @@
                 </a:solidFill>
                 <a:latin typeface="Calibri"/>
               </a:rPr>
-              <a:t>The user asked for nothing harmful. The dangerous orders were </a:t>
+              <a:t>The lookup was innocent. The dangerous orders rode in on the record, </a:t>
             </a:r>
             <a:r>
               <a:rPr sz="1400" b="1" i="0">
@@ -5729,7 +7057,7 @@
                 </a:solidFill>
                 <a:latin typeface="Calibri"/>
               </a:rPr>
-              <a:t>hidden inside data the agent read and trusted</a:t>
+              <a:t>hidden in a notes field the agent read and trusted</a:t>
             </a:r>
             <a:r>
               <a:rPr sz="1400" b="0" i="0">
@@ -6629,8 +7957,8 @@
         </p:nvSpPr>
         <p:spPr>
           <a:xfrm>
-            <a:off x="548640" y="5806440"/>
-            <a:ext cx="11094415" cy="457200"/>
+            <a:off x="548640" y="5760720"/>
+            <a:ext cx="11094415" cy="548640"/>
           </a:xfrm>
           <a:prstGeom prst="rect">
             <a:avLst/>
@@ -6645,13 +7973,31 @@
           <a:p>
             <a:pPr algn="l"/>
             <a:r>
-              <a:rPr sz="1200" b="0" i="1">
+              <a:rPr sz="1250" b="0" i="1">
                 <a:solidFill>
                   <a:srgbClr val="5E7278"/>
                 </a:solidFill>
                 <a:latin typeface="Calibri"/>
               </a:rPr>
-              <a:t>A careful AI refused the obvious trick and fell for the realistic one. What kept it safe was the permission rules, not the AI itself.</a:t>
+              <a:t>A careful AI refused the obvious trick and fell for the realistic one. What stopped it was the </a:t>
+            </a:r>
+            <a:r>
+              <a:rPr sz="1250" b="1" i="1">
+                <a:solidFill>
+                  <a:srgbClr val="1F6F78"/>
+                </a:solidFill>
+                <a:latin typeface="Calibri"/>
+              </a:rPr>
+              <a:t>permissions layer</a:t>
+            </a:r>
+            <a:r>
+              <a:rPr sz="1250" b="0" i="1">
+                <a:solidFill>
+                  <a:srgbClr val="5E7278"/>
+                </a:solidFill>
+                <a:latin typeface="Calibri"/>
+              </a:rPr>
+              <a:t>, the core of the defence onion. Not prompting, not the model itself. We did not fix the LLM; we fixed what the agent was allowed to do.</a:t>
             </a:r>
           </a:p>
         </p:txBody>
@@ -6817,7 +8163,7 @@
                 </a:solidFill>
                 <a:latin typeface="Cambria"/>
               </a:rPr>
-              <a:t>Real incidents you can point to</a:t>
+              <a:t>Real example incidents</a:t>
             </a:r>
           </a:p>
         </p:txBody>
@@ -7436,7 +8782,7 @@
                 </a:solidFill>
                 <a:latin typeface="Calibri"/>
               </a:rPr>
-              <a:t>TAKE-HOME PACKAGE</a:t>
+              <a:t>WORK PACKAGES</a:t>
             </a:r>
           </a:p>
         </p:txBody>
@@ -7471,21 +8817,56 @@
                 </a:solidFill>
                 <a:latin typeface="Cambria"/>
               </a:rPr>
-              <a:t>15 notebooks, three tracks, one repository</a:t>
-            </a:r>
-          </a:p>
-        </p:txBody>
-      </p:sp>
-      <p:sp>
-        <p:nvSpPr>
-          <p:cNvPr id="6" name="Rounded Rectangle 5"/>
+              <a:t>How the training serves WP3 and WP7</a:t>
+            </a:r>
+          </a:p>
+        </p:txBody>
+      </p:sp>
+      <p:sp>
+        <p:nvSpPr>
+          <p:cNvPr id="6" name="TextBox 5"/>
+          <p:cNvSpPr txBox="1"/>
+          <p:nvPr/>
+        </p:nvSpPr>
+        <p:spPr>
+          <a:xfrm>
+            <a:off x="548640" y="1554480"/>
+            <a:ext cx="11094415" cy="365760"/>
+          </a:xfrm>
+          <a:prstGeom prst="rect">
+            <a:avLst/>
+          </a:prstGeom>
+          <a:noFill/>
+        </p:spPr>
+        <p:txBody>
+          <a:bodyPr wrap="square" anchor="t" lIns="0" rIns="0" tIns="0" bIns="0">
+            <a:spAutoFit/>
+          </a:bodyPr>
+          <a:lstStyle/>
+          <a:p>
+            <a:pPr algn="l"/>
+            <a:r>
+              <a:rPr sz="1600" b="0" i="0">
+                <a:solidFill>
+                  <a:srgbClr val="1B2A30"/>
+                </a:solidFill>
+                <a:latin typeface="Calibri"/>
+              </a:rPr>
+              <a:t>It fits two work packages directly:</a:t>
+            </a:r>
+          </a:p>
+        </p:txBody>
+      </p:sp>
+      <p:sp>
+        <p:nvSpPr>
+          <p:cNvPr id="7" name="Rounded Rectangle 6"/>
           <p:cNvSpPr/>
           <p:nvPr/>
         </p:nvSpPr>
         <p:spPr>
           <a:xfrm>
-            <a:off x="548640" y="1463040"/>
-            <a:ext cx="3515258" cy="1417320"/>
+            <a:off x="548640" y="2194560"/>
+            <a:ext cx="5318607" cy="1920240"/>
           </a:xfrm>
           <a:prstGeom prst="roundRect">
             <a:avLst/>
@@ -7524,14 +8905,14 @@
       </p:sp>
       <p:sp>
         <p:nvSpPr>
-          <p:cNvPr id="7" name="TextBox 6"/>
+          <p:cNvPr id="8" name="TextBox 7"/>
           <p:cNvSpPr txBox="1"/>
           <p:nvPr/>
         </p:nvSpPr>
         <p:spPr>
           <a:xfrm>
-            <a:off x="777240" y="1554480"/>
-            <a:ext cx="2326538" cy="365760"/>
+            <a:off x="868680" y="2423160"/>
+            <a:ext cx="4678527" cy="457200"/>
           </a:xfrm>
           <a:prstGeom prst="rect">
             <a:avLst/>
@@ -7546,48 +8927,13 @@
           <a:p>
             <a:pPr algn="l"/>
             <a:r>
-              <a:rPr sz="1800" b="1" i="0">
-                <a:solidFill>
-                  <a:srgbClr val="FFFFFF"/>
-                </a:solidFill>
-                <a:latin typeface="Cambria"/>
-              </a:rPr>
-              <a:t>Builder</a:t>
-            </a:r>
-          </a:p>
-        </p:txBody>
-      </p:sp>
-      <p:sp>
-        <p:nvSpPr>
-          <p:cNvPr id="8" name="TextBox 7"/>
-          <p:cNvSpPr txBox="1"/>
-          <p:nvPr/>
-        </p:nvSpPr>
-        <p:spPr>
-          <a:xfrm>
-            <a:off x="3058058" y="1554480"/>
-            <a:ext cx="777240" cy="365760"/>
-          </a:xfrm>
-          <a:prstGeom prst="rect">
-            <a:avLst/>
-          </a:prstGeom>
-          <a:noFill/>
-        </p:spPr>
-        <p:txBody>
-          <a:bodyPr wrap="square" anchor="t" lIns="0" rIns="0" tIns="0" bIns="0">
-            <a:spAutoFit/>
-          </a:bodyPr>
-          <a:lstStyle/>
-          <a:p>
-            <a:pPr algn="r"/>
-            <a:r>
-              <a:rPr sz="1600" b="1" i="0">
+              <a:rPr sz="2200" b="1" i="0">
                 <a:solidFill>
                   <a:srgbClr val="F2A541"/>
                 </a:solidFill>
                 <a:latin typeface="Cambria"/>
               </a:rPr>
-              <a:t>~7 h</a:t>
+              <a:t>WP3 · T3.1</a:t>
             </a:r>
           </a:p>
         </p:txBody>
@@ -7600,8 +8946,8 @@
         </p:nvSpPr>
         <p:spPr>
           <a:xfrm>
-            <a:off x="777240" y="1938528"/>
-            <a:ext cx="3058058" cy="365760"/>
+            <a:off x="868680" y="2971800"/>
+            <a:ext cx="4678527" cy="1005840"/>
           </a:xfrm>
           <a:prstGeom prst="rect">
             <a:avLst/>
@@ -7616,62 +8962,27 @@
           <a:p>
             <a:pPr algn="l"/>
             <a:r>
-              <a:rPr sz="1200" b="0" i="0">
-                <a:solidFill>
-                  <a:srgbClr val="A9C0C4"/>
-                </a:solidFill>
-                <a:latin typeface="Calibri"/>
-              </a:rPr>
-              <a:t>SME developers shipping an agent</a:t>
-            </a:r>
-          </a:p>
-        </p:txBody>
-      </p:sp>
-      <p:sp>
-        <p:nvSpPr>
-          <p:cNvPr id="10" name="TextBox 9"/>
-          <p:cNvSpPr txBox="1"/>
-          <p:nvPr/>
-        </p:nvSpPr>
-        <p:spPr>
-          <a:xfrm>
-            <a:off x="777240" y="2395728"/>
-            <a:ext cx="3058058" cy="365760"/>
-          </a:xfrm>
-          <a:prstGeom prst="rect">
-            <a:avLst/>
-          </a:prstGeom>
-          <a:noFill/>
-        </p:spPr>
-        <p:txBody>
-          <a:bodyPr wrap="square" anchor="t" lIns="0" rIns="0" tIns="0" bIns="0">
-            <a:spAutoFit/>
-          </a:bodyPr>
-          <a:lstStyle/>
-          <a:p>
-            <a:pPr algn="l"/>
-            <a:r>
-              <a:rPr sz="1250" b="1" i="0">
+              <a:rPr sz="1500" b="0" i="0">
                 <a:solidFill>
                   <a:srgbClr val="FFFFFF"/>
                 </a:solidFill>
                 <a:latin typeface="Calibri"/>
               </a:rPr>
-              <a:t>00 01 03 06 07 08 11 12 14</a:t>
-            </a:r>
-          </a:p>
-        </p:txBody>
-      </p:sp>
-      <p:sp>
-        <p:nvSpPr>
-          <p:cNvPr id="11" name="Rounded Rectangle 10"/>
+              <a:t>The lab is the “sandboxed emulator” the task asks for, and the pack ends in the conformity / ethics self-assessment.</a:t>
+            </a:r>
+          </a:p>
+        </p:txBody>
+      </p:sp>
+      <p:sp>
+        <p:nvSpPr>
+          <p:cNvPr id="10" name="Rounded Rectangle 9"/>
           <p:cNvSpPr/>
           <p:nvPr/>
         </p:nvSpPr>
         <p:spPr>
           <a:xfrm>
-            <a:off x="4338218" y="1463040"/>
-            <a:ext cx="3515258" cy="1417320"/>
+            <a:off x="6324447" y="2194560"/>
+            <a:ext cx="5318607" cy="1920240"/>
           </a:xfrm>
           <a:prstGeom prst="roundRect">
             <a:avLst/>
@@ -7710,14 +9021,14 @@
       </p:sp>
       <p:sp>
         <p:nvSpPr>
-          <p:cNvPr id="12" name="TextBox 11"/>
+          <p:cNvPr id="11" name="TextBox 10"/>
           <p:cNvSpPr txBox="1"/>
           <p:nvPr/>
         </p:nvSpPr>
         <p:spPr>
           <a:xfrm>
-            <a:off x="4566818" y="1554480"/>
-            <a:ext cx="2326538" cy="365760"/>
+            <a:off x="6644487" y="2423160"/>
+            <a:ext cx="4678527" cy="457200"/>
           </a:xfrm>
           <a:prstGeom prst="rect">
             <a:avLst/>
@@ -7732,62 +9043,27 @@
           <a:p>
             <a:pPr algn="l"/>
             <a:r>
-              <a:rPr sz="1800" b="1" i="0">
-                <a:solidFill>
-                  <a:srgbClr val="FFFFFF"/>
-                </a:solidFill>
-                <a:latin typeface="Cambria"/>
-              </a:rPr>
-              <a:t>Researcher</a:t>
-            </a:r>
-          </a:p>
-        </p:txBody>
-      </p:sp>
-      <p:sp>
-        <p:nvSpPr>
-          <p:cNvPr id="13" name="TextBox 12"/>
-          <p:cNvSpPr txBox="1"/>
-          <p:nvPr/>
-        </p:nvSpPr>
-        <p:spPr>
-          <a:xfrm>
-            <a:off x="6847636" y="1554480"/>
-            <a:ext cx="777240" cy="365760"/>
-          </a:xfrm>
-          <a:prstGeom prst="rect">
-            <a:avLst/>
-          </a:prstGeom>
-          <a:noFill/>
-        </p:spPr>
-        <p:txBody>
-          <a:bodyPr wrap="square" anchor="t" lIns="0" rIns="0" tIns="0" bIns="0">
-            <a:spAutoFit/>
-          </a:bodyPr>
-          <a:lstStyle/>
-          <a:p>
-            <a:pPr algn="r"/>
-            <a:r>
-              <a:rPr sz="1600" b="1" i="0">
+              <a:rPr sz="2200" b="1" i="0">
                 <a:solidFill>
                   <a:srgbClr val="F2A541"/>
                 </a:solidFill>
                 <a:latin typeface="Cambria"/>
               </a:rPr>
-              <a:t>~5 h</a:t>
-            </a:r>
-          </a:p>
-        </p:txBody>
-      </p:sp>
-      <p:sp>
-        <p:nvSpPr>
-          <p:cNvPr id="14" name="TextBox 13"/>
+              <a:t>WP7 · T7.3</a:t>
+            </a:r>
+          </a:p>
+        </p:txBody>
+      </p:sp>
+      <p:sp>
+        <p:nvSpPr>
+          <p:cNvPr id="12" name="TextBox 11"/>
           <p:cNvSpPr txBox="1"/>
           <p:nvPr/>
         </p:nvSpPr>
         <p:spPr>
           <a:xfrm>
-            <a:off x="4566818" y="1938528"/>
-            <a:ext cx="3058058" cy="365760"/>
+            <a:off x="6644487" y="2971800"/>
+            <a:ext cx="4678527" cy="1005840"/>
           </a:xfrm>
           <a:prstGeom prst="rect">
             <a:avLst/>
@@ -7802,108 +9078,27 @@
           <a:p>
             <a:pPr algn="l"/>
             <a:r>
-              <a:rPr sz="1200" b="0" i="0">
-                <a:solidFill>
-                  <a:srgbClr val="A9C0C4"/>
-                </a:solidFill>
-                <a:latin typeface="Calibri"/>
-              </a:rPr>
-              <a:t>Students, early-career researchers</a:t>
-            </a:r>
-          </a:p>
-        </p:txBody>
-      </p:sp>
-      <p:sp>
-        <p:nvSpPr>
-          <p:cNvPr id="15" name="TextBox 14"/>
-          <p:cNvSpPr txBox="1"/>
-          <p:nvPr/>
-        </p:nvSpPr>
-        <p:spPr>
-          <a:xfrm>
-            <a:off x="4566818" y="2395728"/>
-            <a:ext cx="3058058" cy="365760"/>
-          </a:xfrm>
-          <a:prstGeom prst="rect">
-            <a:avLst/>
-          </a:prstGeom>
-          <a:noFill/>
-        </p:spPr>
-        <p:txBody>
-          <a:bodyPr wrap="square" anchor="t" lIns="0" rIns="0" tIns="0" bIns="0">
-            <a:spAutoFit/>
-          </a:bodyPr>
-          <a:lstStyle/>
-          <a:p>
-            <a:pPr algn="l"/>
-            <a:r>
-              <a:rPr sz="1250" b="1" i="0">
+              <a:rPr sz="1500" b="0" i="0">
                 <a:solidFill>
                   <a:srgbClr val="FFFFFF"/>
                 </a:solidFill>
                 <a:latin typeface="Calibri"/>
               </a:rPr>
-              <a:t>00 01 02 04 05 12 13</a:t>
-            </a:r>
-          </a:p>
-        </p:txBody>
-      </p:sp>
-      <p:sp>
-        <p:nvSpPr>
-          <p:cNvPr id="16" name="Rounded Rectangle 15"/>
-          <p:cNvSpPr/>
-          <p:nvPr/>
-        </p:nvSpPr>
-        <p:spPr>
-          <a:xfrm>
-            <a:off x="8127796" y="1463040"/>
-            <a:ext cx="3515258" cy="1417320"/>
-          </a:xfrm>
-          <a:prstGeom prst="roundRect">
-            <a:avLst/>
-          </a:prstGeom>
-          <a:solidFill>
-            <a:srgbClr val="13262F"/>
-          </a:solidFill>
-          <a:ln w="12700">
-            <a:solidFill>
-              <a:srgbClr val="13262F"/>
-            </a:solidFill>
-          </a:ln>
-          <a:effectLst/>
-        </p:spPr>
-        <p:style>
-          <a:lnRef idx="1">
-            <a:schemeClr val="accent1"/>
-          </a:lnRef>
-          <a:fillRef idx="3">
-            <a:schemeClr val="accent1"/>
-          </a:fillRef>
-          <a:effectRef idx="2">
-            <a:schemeClr val="accent1"/>
-          </a:effectRef>
-          <a:fontRef idx="minor">
-            <a:schemeClr val="lt1"/>
-          </a:fontRef>
-        </p:style>
-        <p:txBody>
-          <a:bodyPr rtlCol="0" anchor="ctr"/>
-          <a:lstStyle/>
-          <a:p>
-            <a:pPr algn="ctr"/>
-          </a:p>
-        </p:txBody>
-      </p:sp>
-      <p:sp>
-        <p:nvSpPr>
-          <p:cNvPr id="17" name="TextBox 16"/>
+              <a:t>Modular, hands-on LLM training for the three audiences the task names.</a:t>
+            </a:r>
+          </a:p>
+        </p:txBody>
+      </p:sp>
+      <p:sp>
+        <p:nvSpPr>
+          <p:cNvPr id="13" name="TextBox 12"/>
           <p:cNvSpPr txBox="1"/>
           <p:nvPr/>
         </p:nvSpPr>
         <p:spPr>
           <a:xfrm>
-            <a:off x="8356396" y="1554480"/>
-            <a:ext cx="2326538" cy="365760"/>
+            <a:off x="548640" y="4480560"/>
+            <a:ext cx="11094415" cy="548640"/>
           </a:xfrm>
           <a:prstGeom prst="rect">
             <a:avLst/>
@@ -7918,854 +9113,13 @@
           <a:p>
             <a:pPr algn="l"/>
             <a:r>
-              <a:rPr sz="1800" b="1" i="0">
+              <a:rPr sz="1300" b="0" i="1">
                 <a:solidFill>
-                  <a:srgbClr val="FFFFFF"/>
-                </a:solidFill>
-                <a:latin typeface="Cambria"/>
-              </a:rPr>
-              <a:t>Manager</a:t>
-            </a:r>
-          </a:p>
-        </p:txBody>
-      </p:sp>
-      <p:sp>
-        <p:nvSpPr>
-          <p:cNvPr id="18" name="TextBox 17"/>
-          <p:cNvSpPr txBox="1"/>
-          <p:nvPr/>
-        </p:nvSpPr>
-        <p:spPr>
-          <a:xfrm>
-            <a:off x="10637215" y="1554480"/>
-            <a:ext cx="777240" cy="365760"/>
-          </a:xfrm>
-          <a:prstGeom prst="rect">
-            <a:avLst/>
-          </a:prstGeom>
-          <a:noFill/>
-        </p:spPr>
-        <p:txBody>
-          <a:bodyPr wrap="square" anchor="t" lIns="0" rIns="0" tIns="0" bIns="0">
-            <a:spAutoFit/>
-          </a:bodyPr>
-          <a:lstStyle/>
-          <a:p>
-            <a:pPr algn="r"/>
-            <a:r>
-              <a:rPr sz="1600" b="1" i="0">
-                <a:solidFill>
-                  <a:srgbClr val="F2A541"/>
-                </a:solidFill>
-                <a:latin typeface="Cambria"/>
-              </a:rPr>
-              <a:t>~2 h</a:t>
-            </a:r>
-          </a:p>
-        </p:txBody>
-      </p:sp>
-      <p:sp>
-        <p:nvSpPr>
-          <p:cNvPr id="19" name="TextBox 18"/>
-          <p:cNvSpPr txBox="1"/>
-          <p:nvPr/>
-        </p:nvSpPr>
-        <p:spPr>
-          <a:xfrm>
-            <a:off x="8356396" y="1938528"/>
-            <a:ext cx="3058058" cy="365760"/>
-          </a:xfrm>
-          <a:prstGeom prst="rect">
-            <a:avLst/>
-          </a:prstGeom>
-          <a:noFill/>
-        </p:spPr>
-        <p:txBody>
-          <a:bodyPr wrap="square" anchor="t" lIns="0" rIns="0" tIns="0" bIns="0">
-            <a:spAutoFit/>
-          </a:bodyPr>
-          <a:lstStyle/>
-          <a:p>
-            <a:pPr algn="l"/>
-            <a:r>
-              <a:rPr sz="1200" b="0" i="0">
-                <a:solidFill>
-                  <a:srgbClr val="A9C0C4"/>
+                  <a:srgbClr val="5E7278"/>
                 </a:solidFill>
                 <a:latin typeface="Calibri"/>
               </a:rPr>
-              <a:t>Leads, compliance. Little code</a:t>
-            </a:r>
-          </a:p>
-        </p:txBody>
-      </p:sp>
-      <p:sp>
-        <p:nvSpPr>
-          <p:cNvPr id="20" name="TextBox 19"/>
-          <p:cNvSpPr txBox="1"/>
-          <p:nvPr/>
-        </p:nvSpPr>
-        <p:spPr>
-          <a:xfrm>
-            <a:off x="8356396" y="2395728"/>
-            <a:ext cx="3058058" cy="365760"/>
-          </a:xfrm>
-          <a:prstGeom prst="rect">
-            <a:avLst/>
-          </a:prstGeom>
-          <a:noFill/>
-        </p:spPr>
-        <p:txBody>
-          <a:bodyPr wrap="square" anchor="t" lIns="0" rIns="0" tIns="0" bIns="0">
-            <a:spAutoFit/>
-          </a:bodyPr>
-          <a:lstStyle/>
-          <a:p>
-            <a:pPr algn="l"/>
-            <a:r>
-              <a:rPr sz="1250" b="1" i="0">
-                <a:solidFill>
-                  <a:srgbClr val="FFFFFF"/>
-                </a:solidFill>
-                <a:latin typeface="Calibri"/>
-              </a:rPr>
-              <a:t>01 10 13 + checklist</a:t>
-            </a:r>
-          </a:p>
-        </p:txBody>
-      </p:sp>
-      <p:sp>
-        <p:nvSpPr>
-          <p:cNvPr id="21" name="Rounded Rectangle 20"/>
-          <p:cNvSpPr/>
-          <p:nvPr/>
-        </p:nvSpPr>
-        <p:spPr>
-          <a:xfrm>
-            <a:off x="548640" y="3108960"/>
-            <a:ext cx="2602153" cy="2834640"/>
-          </a:xfrm>
-          <a:prstGeom prst="roundRect">
-            <a:avLst/>
-          </a:prstGeom>
-          <a:solidFill>
-            <a:srgbClr val="EEF4F4"/>
-          </a:solidFill>
-          <a:ln w="12700">
-            <a:solidFill>
-              <a:srgbClr val="EEF4F4"/>
-            </a:solidFill>
-          </a:ln>
-          <a:effectLst/>
-        </p:spPr>
-        <p:style>
-          <a:lnRef idx="1">
-            <a:schemeClr val="accent1"/>
-          </a:lnRef>
-          <a:fillRef idx="3">
-            <a:schemeClr val="accent1"/>
-          </a:fillRef>
-          <a:effectRef idx="2">
-            <a:schemeClr val="accent1"/>
-          </a:effectRef>
-          <a:fontRef idx="minor">
-            <a:schemeClr val="lt1"/>
-          </a:fontRef>
-        </p:style>
-        <p:txBody>
-          <a:bodyPr rtlCol="0" anchor="ctr"/>
-          <a:lstStyle/>
-          <a:p>
-            <a:pPr algn="ctr"/>
-          </a:p>
-        </p:txBody>
-      </p:sp>
-      <p:sp>
-        <p:nvSpPr>
-          <p:cNvPr id="22" name="TextBox 21"/>
-          <p:cNvSpPr txBox="1"/>
-          <p:nvPr/>
-        </p:nvSpPr>
-        <p:spPr>
-          <a:xfrm>
-            <a:off x="731520" y="3200400"/>
-            <a:ext cx="2327833" cy="320040"/>
-          </a:xfrm>
-          <a:prstGeom prst="rect">
-            <a:avLst/>
-          </a:prstGeom>
-          <a:noFill/>
-        </p:spPr>
-        <p:txBody>
-          <a:bodyPr wrap="square" anchor="t" lIns="0" rIns="0" tIns="0" bIns="0">
-            <a:spAutoFit/>
-          </a:bodyPr>
-          <a:lstStyle/>
-          <a:p>
-            <a:pPr algn="l"/>
-            <a:r>
-              <a:rPr sz="1450" b="1" i="0">
-                <a:solidFill>
-                  <a:srgbClr val="1F6F78"/>
-                </a:solidFill>
-                <a:latin typeface="Cambria"/>
-              </a:rPr>
-              <a:t>Every notebook</a:t>
-            </a:r>
-          </a:p>
-        </p:txBody>
-      </p:sp>
-      <p:sp>
-        <p:nvSpPr>
-          <p:cNvPr id="23" name="TextBox 22"/>
-          <p:cNvSpPr txBox="1"/>
-          <p:nvPr/>
-        </p:nvSpPr>
-        <p:spPr>
-          <a:xfrm>
-            <a:off x="731520" y="3566160"/>
-            <a:ext cx="2327833" cy="2286000"/>
-          </a:xfrm>
-          <a:prstGeom prst="rect">
-            <a:avLst/>
-          </a:prstGeom>
-          <a:noFill/>
-        </p:spPr>
-        <p:txBody>
-          <a:bodyPr wrap="square" anchor="t" lIns="0" rIns="0" tIns="0" bIns="0">
-            <a:spAutoFit/>
-          </a:bodyPr>
-          <a:lstStyle/>
-          <a:p>
-            <a:pPr algn="l">
-              <a:spcAft>
-                <a:spcPts val="500"/>
-              </a:spcAft>
-            </a:pPr>
-            <a:r>
-              <a:rPr sz="1150" b="0" i="0">
-                <a:solidFill>
-                  <a:srgbClr val="1B2A30"/>
-                </a:solidFill>
-                <a:latin typeface="Calibri"/>
-              </a:rPr>
-              <a:t>•  Scenario in the mock company</a:t>
-            </a:r>
-          </a:p>
-          <a:p>
-            <a:pPr algn="l">
-              <a:spcAft>
-                <a:spcPts val="500"/>
-              </a:spcAft>
-            </a:pPr>
-            <a:r>
-              <a:rPr sz="1150" b="0" i="0">
-                <a:solidFill>
-                  <a:srgbClr val="1B2A30"/>
-                </a:solidFill>
-                <a:latin typeface="Calibri"/>
-              </a:rPr>
-              <a:t>•  See the problem (unsafe)</a:t>
-            </a:r>
-          </a:p>
-          <a:p>
-            <a:pPr algn="l">
-              <a:spcAft>
-                <a:spcPts val="500"/>
-              </a:spcAft>
-            </a:pPr>
-            <a:r>
-              <a:rPr sz="1150" b="0" i="0">
-                <a:solidFill>
-                  <a:srgbClr val="1B2A30"/>
-                </a:solidFill>
-                <a:latin typeface="Calibri"/>
-              </a:rPr>
-              <a:t>•  Try the obvious fix</a:t>
-            </a:r>
-          </a:p>
-          <a:p>
-            <a:pPr algn="l">
-              <a:spcAft>
-                <a:spcPts val="500"/>
-              </a:spcAft>
-            </a:pPr>
-            <a:r>
-              <a:rPr sz="1150" b="0" i="0">
-                <a:solidFill>
-                  <a:srgbClr val="1B2A30"/>
-                </a:solidFill>
-                <a:latin typeface="Calibri"/>
-              </a:rPr>
-              <a:t>•  Apply the control (hardened)</a:t>
-            </a:r>
-          </a:p>
-          <a:p>
-            <a:pPr algn="l">
-              <a:spcAft>
-                <a:spcPts val="500"/>
-              </a:spcAft>
-            </a:pPr>
-            <a:r>
-              <a:rPr sz="1150" b="0" i="0">
-                <a:solidFill>
-                  <a:srgbClr val="1B2A30"/>
-                </a:solidFill>
-                <a:latin typeface="Calibri"/>
-              </a:rPr>
-              <a:t>•  Try it on your own model / app</a:t>
-            </a:r>
-          </a:p>
-        </p:txBody>
-      </p:sp>
-      <p:sp>
-        <p:nvSpPr>
-          <p:cNvPr id="24" name="Rounded Rectangle 23"/>
-          <p:cNvSpPr/>
-          <p:nvPr/>
-        </p:nvSpPr>
-        <p:spPr>
-          <a:xfrm>
-            <a:off x="3379393" y="3108960"/>
-            <a:ext cx="2602153" cy="2834640"/>
-          </a:xfrm>
-          <a:prstGeom prst="roundRect">
-            <a:avLst/>
-          </a:prstGeom>
-          <a:solidFill>
-            <a:srgbClr val="EEF4F4"/>
-          </a:solidFill>
-          <a:ln w="12700">
-            <a:solidFill>
-              <a:srgbClr val="EEF4F4"/>
-            </a:solidFill>
-          </a:ln>
-          <a:effectLst/>
-        </p:spPr>
-        <p:style>
-          <a:lnRef idx="1">
-            <a:schemeClr val="accent1"/>
-          </a:lnRef>
-          <a:fillRef idx="3">
-            <a:schemeClr val="accent1"/>
-          </a:fillRef>
-          <a:effectRef idx="2">
-            <a:schemeClr val="accent1"/>
-          </a:effectRef>
-          <a:fontRef idx="minor">
-            <a:schemeClr val="lt1"/>
-          </a:fontRef>
-        </p:style>
-        <p:txBody>
-          <a:bodyPr rtlCol="0" anchor="ctr"/>
-          <a:lstStyle/>
-          <a:p>
-            <a:pPr algn="ctr"/>
-          </a:p>
-        </p:txBody>
-      </p:sp>
-      <p:sp>
-        <p:nvSpPr>
-          <p:cNvPr id="25" name="TextBox 24"/>
-          <p:cNvSpPr txBox="1"/>
-          <p:nvPr/>
-        </p:nvSpPr>
-        <p:spPr>
-          <a:xfrm>
-            <a:off x="3562273" y="3200400"/>
-            <a:ext cx="2327833" cy="320040"/>
-          </a:xfrm>
-          <a:prstGeom prst="rect">
-            <a:avLst/>
-          </a:prstGeom>
-          <a:noFill/>
-        </p:spPr>
-        <p:txBody>
-          <a:bodyPr wrap="square" anchor="t" lIns="0" rIns="0" tIns="0" bIns="0">
-            <a:spAutoFit/>
-          </a:bodyPr>
-          <a:lstStyle/>
-          <a:p>
-            <a:pPr algn="l"/>
-            <a:r>
-              <a:rPr sz="1450" b="1" i="0">
-                <a:solidFill>
-                  <a:srgbClr val="1F6F78"/>
-                </a:solidFill>
-                <a:latin typeface="Cambria"/>
-              </a:rPr>
-              <a:t>Topics 00-14</a:t>
-            </a:r>
-          </a:p>
-        </p:txBody>
-      </p:sp>
-      <p:sp>
-        <p:nvSpPr>
-          <p:cNvPr id="26" name="TextBox 25"/>
-          <p:cNvSpPr txBox="1"/>
-          <p:nvPr/>
-        </p:nvSpPr>
-        <p:spPr>
-          <a:xfrm>
-            <a:off x="3562273" y="3566160"/>
-            <a:ext cx="2327833" cy="2286000"/>
-          </a:xfrm>
-          <a:prstGeom prst="rect">
-            <a:avLst/>
-          </a:prstGeom>
-          <a:noFill/>
-        </p:spPr>
-        <p:txBody>
-          <a:bodyPr wrap="square" anchor="t" lIns="0" rIns="0" tIns="0" bIns="0">
-            <a:spAutoFit/>
-          </a:bodyPr>
-          <a:lstStyle/>
-          <a:p>
-            <a:pPr algn="l">
-              <a:spcAft>
-                <a:spcPts val="500"/>
-              </a:spcAft>
-            </a:pPr>
-            <a:r>
-              <a:rPr sz="1150" b="0" i="0">
-                <a:solidFill>
-                  <a:srgbClr val="1B2A30"/>
-                </a:solidFill>
-                <a:latin typeface="Calibri"/>
-              </a:rPr>
-              <a:t>•  Instructions vs data, MCP, RAG</a:t>
-            </a:r>
-          </a:p>
-          <a:p>
-            <a:pPr algn="l">
-              <a:spcAft>
-                <a:spcPts val="500"/>
-              </a:spcAft>
-            </a:pPr>
-            <a:r>
-              <a:rPr sz="1150" b="0" i="0">
-                <a:solidFill>
-                  <a:srgbClr val="1B2A30"/>
-                </a:solidFill>
-                <a:latin typeface="Calibri"/>
-              </a:rPr>
-              <a:t>•  Guardrails bake-off</a:t>
-            </a:r>
-          </a:p>
-          <a:p>
-            <a:pPr algn="l">
-              <a:spcAft>
-                <a:spcPts val="500"/>
-              </a:spcAft>
-            </a:pPr>
-            <a:r>
-              <a:rPr sz="1150" b="0" i="0">
-                <a:solidFill>
-                  <a:srgbClr val="1B2A30"/>
-                </a:solidFill>
-                <a:latin typeface="Calibri"/>
-              </a:rPr>
-              <a:t>•  Safe tools, permissions</a:t>
-            </a:r>
-          </a:p>
-          <a:p>
-            <a:pPr algn="l">
-              <a:spcAft>
-                <a:spcPts val="500"/>
-              </a:spcAft>
-            </a:pPr>
-            <a:r>
-              <a:rPr sz="1150" b="0" i="0">
-                <a:solidFill>
-                  <a:srgbClr val="1B2A30"/>
-                </a:solidFill>
-                <a:latin typeface="Calibri"/>
-              </a:rPr>
-              <a:t>•  Isolated code execution</a:t>
-            </a:r>
-          </a:p>
-          <a:p>
-            <a:pPr algn="l">
-              <a:spcAft>
-                <a:spcPts val="500"/>
-              </a:spcAft>
-            </a:pPr>
-            <a:r>
-              <a:rPr sz="1150" b="0" i="0">
-                <a:solidFill>
-                  <a:srgbClr val="1B2A30"/>
-                </a:solidFill>
-                <a:latin typeface="Calibri"/>
-              </a:rPr>
-              <a:t>•  Memory, data protection</a:t>
-            </a:r>
-          </a:p>
-          <a:p>
-            <a:pPr algn="l">
-              <a:spcAft>
-                <a:spcPts val="500"/>
-              </a:spcAft>
-            </a:pPr>
-            <a:r>
-              <a:rPr sz="1150" b="0" i="0">
-                <a:solidFill>
-                  <a:srgbClr val="1B2A30"/>
-                </a:solidFill>
-                <a:latin typeface="Calibri"/>
-              </a:rPr>
-              <a:t>•  Monitoring, evaluation, governance</a:t>
-            </a:r>
-          </a:p>
-        </p:txBody>
-      </p:sp>
-      <p:sp>
-        <p:nvSpPr>
-          <p:cNvPr id="27" name="Rounded Rectangle 26"/>
-          <p:cNvSpPr/>
-          <p:nvPr/>
-        </p:nvSpPr>
-        <p:spPr>
-          <a:xfrm>
-            <a:off x="6210147" y="3108960"/>
-            <a:ext cx="2602153" cy="2834640"/>
-          </a:xfrm>
-          <a:prstGeom prst="roundRect">
-            <a:avLst/>
-          </a:prstGeom>
-          <a:solidFill>
-            <a:srgbClr val="EEF4F4"/>
-          </a:solidFill>
-          <a:ln w="12700">
-            <a:solidFill>
-              <a:srgbClr val="EEF4F4"/>
-            </a:solidFill>
-          </a:ln>
-          <a:effectLst/>
-        </p:spPr>
-        <p:style>
-          <a:lnRef idx="1">
-            <a:schemeClr val="accent1"/>
-          </a:lnRef>
-          <a:fillRef idx="3">
-            <a:schemeClr val="accent1"/>
-          </a:fillRef>
-          <a:effectRef idx="2">
-            <a:schemeClr val="accent1"/>
-          </a:effectRef>
-          <a:fontRef idx="minor">
-            <a:schemeClr val="lt1"/>
-          </a:fontRef>
-        </p:style>
-        <p:txBody>
-          <a:bodyPr rtlCol="0" anchor="ctr"/>
-          <a:lstStyle/>
-          <a:p>
-            <a:pPr algn="ctr"/>
-          </a:p>
-        </p:txBody>
-      </p:sp>
-      <p:sp>
-        <p:nvSpPr>
-          <p:cNvPr id="28" name="TextBox 27"/>
-          <p:cNvSpPr txBox="1"/>
-          <p:nvPr/>
-        </p:nvSpPr>
-        <p:spPr>
-          <a:xfrm>
-            <a:off x="6393027" y="3200400"/>
-            <a:ext cx="2327833" cy="320040"/>
-          </a:xfrm>
-          <a:prstGeom prst="rect">
-            <a:avLst/>
-          </a:prstGeom>
-          <a:noFill/>
-        </p:spPr>
-        <p:txBody>
-          <a:bodyPr wrap="square" anchor="t" lIns="0" rIns="0" tIns="0" bIns="0">
-            <a:spAutoFit/>
-          </a:bodyPr>
-          <a:lstStyle/>
-          <a:p>
-            <a:pPr algn="l"/>
-            <a:r>
-              <a:rPr sz="1450" b="1" i="0">
-                <a:solidFill>
-                  <a:srgbClr val="1F6F78"/>
-                </a:solidFill>
-                <a:latin typeface="Cambria"/>
-              </a:rPr>
-              <a:t>Any model</a:t>
-            </a:r>
-          </a:p>
-        </p:txBody>
-      </p:sp>
-      <p:sp>
-        <p:nvSpPr>
-          <p:cNvPr id="29" name="TextBox 28"/>
-          <p:cNvSpPr txBox="1"/>
-          <p:nvPr/>
-        </p:nvSpPr>
-        <p:spPr>
-          <a:xfrm>
-            <a:off x="6393027" y="3566160"/>
-            <a:ext cx="2327833" cy="2286000"/>
-          </a:xfrm>
-          <a:prstGeom prst="rect">
-            <a:avLst/>
-          </a:prstGeom>
-          <a:noFill/>
-        </p:spPr>
-        <p:txBody>
-          <a:bodyPr wrap="square" anchor="t" lIns="0" rIns="0" tIns="0" bIns="0">
-            <a:spAutoFit/>
-          </a:bodyPr>
-          <a:lstStyle/>
-          <a:p>
-            <a:pPr algn="l">
-              <a:spcAft>
-                <a:spcPts val="500"/>
-              </a:spcAft>
-            </a:pPr>
-            <a:r>
-              <a:rPr sz="1150" b="0" i="0">
-                <a:solidFill>
-                  <a:srgbClr val="1B2A30"/>
-                </a:solidFill>
-                <a:latin typeface="Calibri"/>
-              </a:rPr>
-              <a:t>•  One config.yaml switchboard</a:t>
-            </a:r>
-          </a:p>
-          <a:p>
-            <a:pPr algn="l">
-              <a:spcAft>
-                <a:spcPts val="500"/>
-              </a:spcAft>
-            </a:pPr>
-            <a:r>
-              <a:rPr sz="1150" b="0" i="0">
-                <a:solidFill>
-                  <a:srgbClr val="1B2A30"/>
-                </a:solidFill>
-                <a:latin typeface="Calibri"/>
-              </a:rPr>
-              <a:t>•  Default: small local models</a:t>
-            </a:r>
-          </a:p>
-          <a:p>
-            <a:pPr algn="l">
-              <a:spcAft>
-                <a:spcPts val="500"/>
-              </a:spcAft>
-            </a:pPr>
-            <a:r>
-              <a:rPr sz="1150" b="0" i="0">
-                <a:solidFill>
-                  <a:srgbClr val="1B2A30"/>
-                </a:solidFill>
-                <a:latin typeface="Calibri"/>
-              </a:rPr>
-              <a:t>•  Optional: own cloud API key</a:t>
-            </a:r>
-          </a:p>
-          <a:p>
-            <a:pPr algn="l">
-              <a:spcAft>
-                <a:spcPts val="500"/>
-              </a:spcAft>
-            </a:pPr>
-            <a:r>
-              <a:rPr sz="1150" b="0" i="0">
-                <a:solidFill>
-                  <a:srgbClr val="1B2A30"/>
-                </a:solidFill>
-                <a:latin typeface="Calibri"/>
-              </a:rPr>
-              <a:t>•  HPC models: out of scope</a:t>
-            </a:r>
-          </a:p>
-        </p:txBody>
-      </p:sp>
-      <p:sp>
-        <p:nvSpPr>
-          <p:cNvPr id="30" name="Rounded Rectangle 29"/>
-          <p:cNvSpPr/>
-          <p:nvPr/>
-        </p:nvSpPr>
-        <p:spPr>
-          <a:xfrm>
-            <a:off x="9040901" y="3108960"/>
-            <a:ext cx="2602153" cy="2834640"/>
-          </a:xfrm>
-          <a:prstGeom prst="roundRect">
-            <a:avLst/>
-          </a:prstGeom>
-          <a:solidFill>
-            <a:srgbClr val="EEF4F4"/>
-          </a:solidFill>
-          <a:ln w="12700">
-            <a:solidFill>
-              <a:srgbClr val="EEF4F4"/>
-            </a:solidFill>
-          </a:ln>
-          <a:effectLst/>
-        </p:spPr>
-        <p:style>
-          <a:lnRef idx="1">
-            <a:schemeClr val="accent1"/>
-          </a:lnRef>
-          <a:fillRef idx="3">
-            <a:schemeClr val="accent1"/>
-          </a:fillRef>
-          <a:effectRef idx="2">
-            <a:schemeClr val="accent1"/>
-          </a:effectRef>
-          <a:fontRef idx="minor">
-            <a:schemeClr val="lt1"/>
-          </a:fontRef>
-        </p:style>
-        <p:txBody>
-          <a:bodyPr rtlCol="0" anchor="ctr"/>
-          <a:lstStyle/>
-          <a:p>
-            <a:pPr algn="ctr"/>
-          </a:p>
-        </p:txBody>
-      </p:sp>
-      <p:sp>
-        <p:nvSpPr>
-          <p:cNvPr id="31" name="TextBox 30"/>
-          <p:cNvSpPr txBox="1"/>
-          <p:nvPr/>
-        </p:nvSpPr>
-        <p:spPr>
-          <a:xfrm>
-            <a:off x="9223781" y="3200400"/>
-            <a:ext cx="2327833" cy="320040"/>
-          </a:xfrm>
-          <a:prstGeom prst="rect">
-            <a:avLst/>
-          </a:prstGeom>
-          <a:noFill/>
-        </p:spPr>
-        <p:txBody>
-          <a:bodyPr wrap="square" anchor="t" lIns="0" rIns="0" tIns="0" bIns="0">
-            <a:spAutoFit/>
-          </a:bodyPr>
-          <a:lstStyle/>
-          <a:p>
-            <a:pPr algn="l"/>
-            <a:r>
-              <a:rPr sz="1450" b="1" i="0">
-                <a:solidFill>
-                  <a:srgbClr val="1F6F78"/>
-                </a:solidFill>
-                <a:latin typeface="Cambria"/>
-              </a:rPr>
-              <a:t>Also in the box</a:t>
-            </a:r>
-          </a:p>
-        </p:txBody>
-      </p:sp>
-      <p:sp>
-        <p:nvSpPr>
-          <p:cNvPr id="32" name="TextBox 31"/>
-          <p:cNvSpPr txBox="1"/>
-          <p:nvPr/>
-        </p:nvSpPr>
-        <p:spPr>
-          <a:xfrm>
-            <a:off x="9223781" y="3566160"/>
-            <a:ext cx="2327833" cy="2286000"/>
-          </a:xfrm>
-          <a:prstGeom prst="rect">
-            <a:avLst/>
-          </a:prstGeom>
-          <a:noFill/>
-        </p:spPr>
-        <p:txBody>
-          <a:bodyPr wrap="square" anchor="t" lIns="0" rIns="0" tIns="0" bIns="0">
-            <a:spAutoFit/>
-          </a:bodyPr>
-          <a:lstStyle/>
-          <a:p>
-            <a:pPr algn="l">
-              <a:spcAft>
-                <a:spcPts val="500"/>
-              </a:spcAft>
-            </a:pPr>
-            <a:r>
-              <a:rPr sz="1150" b="0" i="0">
-                <a:solidFill>
-                  <a:srgbClr val="1B2A30"/>
-                </a:solidFill>
-                <a:latin typeface="Calibri"/>
-              </a:rPr>
-              <a:t>•  Mock company (docker compose)</a:t>
-            </a:r>
-          </a:p>
-          <a:p>
-            <a:pPr algn="l">
-              <a:spcAft>
-                <a:spcPts val="500"/>
-              </a:spcAft>
-            </a:pPr>
-            <a:r>
-              <a:rPr sz="1150" b="0" i="0">
-                <a:solidFill>
-                  <a:srgbClr val="1B2A30"/>
-                </a:solidFill>
-                <a:latin typeface="Calibri"/>
-              </a:rPr>
-              <a:t>•  Evaluation harness + scorecard</a:t>
-            </a:r>
-          </a:p>
-          <a:p>
-            <a:pPr algn="l">
-              <a:spcAft>
-                <a:spcPts val="500"/>
-              </a:spcAft>
-            </a:pPr>
-            <a:r>
-              <a:rPr sz="1150" b="0" i="0">
-                <a:solidFill>
-                  <a:srgbClr val="1B2A30"/>
-                </a:solidFill>
-                <a:latin typeface="Calibri"/>
-              </a:rPr>
-              <a:t>•  Deployment checklist, templates</a:t>
-            </a:r>
-          </a:p>
-          <a:p>
-            <a:pPr algn="l">
-              <a:spcAft>
-                <a:spcPts val="500"/>
-              </a:spcAft>
-            </a:pPr>
-            <a:r>
-              <a:rPr sz="1150" b="0" i="0">
-                <a:solidFill>
-                  <a:srgbClr val="1B2A30"/>
-                </a:solidFill>
-                <a:latin typeface="Calibri"/>
-              </a:rPr>
-              <a:t>•  Self-assessment form (T3.1)</a:t>
-            </a:r>
-          </a:p>
-          <a:p>
-            <a:pPr algn="l">
-              <a:spcAft>
-                <a:spcPts val="500"/>
-              </a:spcAft>
-            </a:pPr>
-            <a:r>
-              <a:rPr sz="1150" b="0" i="0">
-                <a:solidFill>
-                  <a:srgbClr val="1B2A30"/>
-                </a:solidFill>
-                <a:latin typeface="Calibri"/>
-              </a:rPr>
-              <a:t>•  Instructor guide, quizzes</a:t>
+              <a:t>Other WP3/WP7 tasks (data access, secure environments, the Training Hub repository, guest lectures) are touched by specific notebooks: detail on request.</a:t>
             </a:r>
           </a:p>
         </p:txBody>
@@ -8779,7 +9133,7 @@
 </file>
 
 <file path=ppt/slides/slide8.xml><?xml version="1.0" encoding="utf-8"?>
-<p:sld xmlns:a="http://schemas.openxmlformats.org/drawingml/2006/main" xmlns:p="http://schemas.openxmlformats.org/presentationml/2006/main" xmlns:r="http://schemas.openxmlformats.org/officeDocument/2006/relationships">
+<p:sld xmlns:a="http://schemas.openxmlformats.org/drawingml/2006/main" xmlns:p="http://schemas.openxmlformats.org/presentationml/2006/main" xmlns:r="http://schemas.openxmlformats.org/officeDocument/2006/relationships" show="0">
   <p:cSld>
     <p:bg>
       <p:bgPr>
@@ -8896,7 +9250,7 @@
                 </a:solidFill>
                 <a:latin typeface="Calibri"/>
               </a:rPr>
-              <a:t>WORK PACKAGES</a:t>
+              <a:t>APPENDIX</a:t>
             </a:r>
           </a:p>
         </p:txBody>
@@ -8925,27 +9279,901 @@
           <a:p>
             <a:pPr algn="l"/>
             <a:r>
-              <a:rPr sz="3000" b="1" i="0">
+              <a:rPr sz="2400" b="1" i="0">
                 <a:solidFill>
                   <a:srgbClr val="13262F"/>
                 </a:solidFill>
                 <a:latin typeface="Cambria"/>
               </a:rPr>
-              <a:t>How the training serves WP3 and WP7</a:t>
-            </a:r>
-          </a:p>
-        </p:txBody>
-      </p:sp>
-      <p:sp>
-        <p:nvSpPr>
-          <p:cNvPr id="6" name="TextBox 5"/>
+              <a:t>How the topics map to the Open Worldwide Application Security Project</a:t>
+            </a:r>
+          </a:p>
+        </p:txBody>
+      </p:sp>
+      <p:graphicFrame>
+        <p:nvGraphicFramePr>
+          <p:cNvPr id="6" name="Table 5"/>
+          <p:cNvGraphicFramePr>
+            <a:graphicFrameLocks noGrp="1"/>
+          </p:cNvGraphicFramePr>
+          <p:nvPr/>
+        </p:nvGraphicFramePr>
+        <p:xfrm>
+          <a:off x="548640" y="1417320"/>
+          <a:ext cx="11091672" cy="4526280"/>
+        </p:xfrm>
+        <a:graphic>
+          <a:graphicData uri="http://schemas.openxmlformats.org/drawingml/2006/table">
+            <a:tbl>
+              <a:tblPr firstRow="1" bandRow="1">
+                <a:tableStyleId>{5C22544A-7EE6-4342-B048-85BDC9FD1C3A}</a:tableStyleId>
+              </a:tblPr>
+              <a:tblGrid>
+                <a:gridCol w="2743200"/>
+                <a:gridCol w="2926080"/>
+                <a:gridCol w="3291840"/>
+                <a:gridCol w="2130552"/>
+              </a:tblGrid>
+              <a:tr h="502920">
+                <a:tc>
+                  <a:txBody>
+                    <a:bodyPr/>
+                    <a:lstStyle/>
+                    <a:p>
+                      <a:pPr algn="l"/>
+                      <a:r>
+                        <a:rPr sz="1150" b="1">
+                          <a:solidFill>
+                            <a:srgbClr val="FFFFFF"/>
+                          </a:solidFill>
+                          <a:latin typeface="Calibri"/>
+                        </a:rPr>
+                        <a:t>Topic</a:t>
+                      </a:r>
+                    </a:p>
+                  </a:txBody>
+                  <a:tcPr marL="73152" marR="73152" marT="27432" marB="27432" anchor="ctr">
+                    <a:solidFill>
+                      <a:srgbClr val="1F6F78"/>
+                    </a:solidFill>
+                  </a:tcPr>
+                </a:tc>
+                <a:tc>
+                  <a:txBody>
+                    <a:bodyPr/>
+                    <a:lstStyle/>
+                    <a:p>
+                      <a:pPr algn="l"/>
+                      <a:r>
+                        <a:rPr sz="1150" b="1">
+                          <a:solidFill>
+                            <a:srgbClr val="FFFFFF"/>
+                          </a:solidFill>
+                          <a:latin typeface="Calibri"/>
+                        </a:rPr>
+                        <a:t>OWASP LLM Top 10</a:t>
+                      </a:r>
+                    </a:p>
+                  </a:txBody>
+                  <a:tcPr marL="73152" marR="73152" marT="27432" marB="27432" anchor="ctr">
+                    <a:solidFill>
+                      <a:srgbClr val="1F6F78"/>
+                    </a:solidFill>
+                  </a:tcPr>
+                </a:tc>
+                <a:tc>
+                  <a:txBody>
+                    <a:bodyPr/>
+                    <a:lstStyle/>
+                    <a:p>
+                      <a:pPr algn="l"/>
+                      <a:r>
+                        <a:rPr sz="1150" b="1">
+                          <a:solidFill>
+                            <a:srgbClr val="FFFFFF"/>
+                          </a:solidFill>
+                          <a:latin typeface="Calibri"/>
+                        </a:rPr>
+                        <a:t>OWASP Agentic Top 10</a:t>
+                      </a:r>
+                    </a:p>
+                  </a:txBody>
+                  <a:tcPr marL="73152" marR="73152" marT="27432" marB="27432" anchor="ctr">
+                    <a:solidFill>
+                      <a:srgbClr val="1F6F78"/>
+                    </a:solidFill>
+                  </a:tcPr>
+                </a:tc>
+                <a:tc>
+                  <a:txBody>
+                    <a:bodyPr/>
+                    <a:lstStyle/>
+                    <a:p>
+                      <a:pPr algn="l"/>
+                      <a:r>
+                        <a:rPr sz="1150" b="1">
+                          <a:solidFill>
+                            <a:srgbClr val="FFFFFF"/>
+                          </a:solidFill>
+                          <a:latin typeface="Calibri"/>
+                        </a:rPr>
+                        <a:t>Other standards</a:t>
+                      </a:r>
+                    </a:p>
+                  </a:txBody>
+                  <a:tcPr marL="73152" marR="73152" marT="27432" marB="27432" anchor="ctr">
+                    <a:solidFill>
+                      <a:srgbClr val="1F6F78"/>
+                    </a:solidFill>
+                  </a:tcPr>
+                </a:tc>
+              </a:tr>
+              <a:tr h="502920">
+                <a:tc>
+                  <a:txBody>
+                    <a:bodyPr/>
+                    <a:lstStyle/>
+                    <a:p>
+                      <a:pPr algn="l"/>
+                      <a:r>
+                        <a:rPr sz="1050" b="1">
+                          <a:solidFill>
+                            <a:srgbClr val="1B2A30"/>
+                          </a:solidFill>
+                          <a:latin typeface="Calibri"/>
+                        </a:rPr>
+                        <a:t>1  Instructions vs data</a:t>
+                      </a:r>
+                    </a:p>
+                  </a:txBody>
+                  <a:tcPr marL="73152" marR="73152" marT="27432" marB="27432" anchor="ctr">
+                    <a:solidFill>
+                      <a:srgbClr val="FFFFFF"/>
+                    </a:solidFill>
+                  </a:tcPr>
+                </a:tc>
+                <a:tc>
+                  <a:txBody>
+                    <a:bodyPr/>
+                    <a:lstStyle/>
+                    <a:p>
+                      <a:pPr algn="l"/>
+                      <a:r>
+                        <a:rPr sz="1050" b="0">
+                          <a:solidFill>
+                            <a:srgbClr val="5E7278"/>
+                          </a:solidFill>
+                          <a:latin typeface="Calibri"/>
+                        </a:rPr>
+                        <a:t>LLM01 Prompt Injection</a:t>
+                      </a:r>
+                    </a:p>
+                  </a:txBody>
+                  <a:tcPr marL="73152" marR="73152" marT="27432" marB="27432" anchor="ctr">
+                    <a:solidFill>
+                      <a:srgbClr val="FFFFFF"/>
+                    </a:solidFill>
+                  </a:tcPr>
+                </a:tc>
+                <a:tc>
+                  <a:txBody>
+                    <a:bodyPr/>
+                    <a:lstStyle/>
+                    <a:p>
+                      <a:pPr algn="l"/>
+                      <a:r>
+                        <a:rPr sz="1050" b="0">
+                          <a:solidFill>
+                            <a:srgbClr val="5E7278"/>
+                          </a:solidFill>
+                          <a:latin typeface="Calibri"/>
+                        </a:rPr>
+                        <a:t>ASI01 Goal Hijack</a:t>
+                      </a:r>
+                    </a:p>
+                  </a:txBody>
+                  <a:tcPr marL="73152" marR="73152" marT="27432" marB="27432" anchor="ctr">
+                    <a:solidFill>
+                      <a:srgbClr val="FFFFFF"/>
+                    </a:solidFill>
+                  </a:tcPr>
+                </a:tc>
+                <a:tc>
+                  <a:txBody>
+                    <a:bodyPr/>
+                    <a:lstStyle/>
+                    <a:p>
+                      <a:pPr algn="l"/>
+                      <a:r>
+                        <a:rPr sz="1050" b="0">
+                          <a:solidFill>
+                            <a:srgbClr val="5E7278"/>
+                          </a:solidFill>
+                          <a:latin typeface="Calibri"/>
+                        </a:rPr>
+                        <a:t/>
+                      </a:r>
+                    </a:p>
+                  </a:txBody>
+                  <a:tcPr marL="73152" marR="73152" marT="27432" marB="27432" anchor="ctr">
+                    <a:solidFill>
+                      <a:srgbClr val="FFFFFF"/>
+                    </a:solidFill>
+                  </a:tcPr>
+                </a:tc>
+              </a:tr>
+              <a:tr h="502920">
+                <a:tc>
+                  <a:txBody>
+                    <a:bodyPr/>
+                    <a:lstStyle/>
+                    <a:p>
+                      <a:pPr algn="l"/>
+                      <a:r>
+                        <a:rPr sz="1050" b="1">
+                          <a:solidFill>
+                            <a:srgbClr val="1B2A30"/>
+                          </a:solidFill>
+                          <a:latin typeface="Calibri"/>
+                        </a:rPr>
+                        <a:t>2  Documents and RAG</a:t>
+                      </a:r>
+                    </a:p>
+                  </a:txBody>
+                  <a:tcPr marL="73152" marR="73152" marT="27432" marB="27432" anchor="ctr">
+                    <a:solidFill>
+                      <a:srgbClr val="EEF4F4"/>
+                    </a:solidFill>
+                  </a:tcPr>
+                </a:tc>
+                <a:tc>
+                  <a:txBody>
+                    <a:bodyPr/>
+                    <a:lstStyle/>
+                    <a:p>
+                      <a:pPr algn="l"/>
+                      <a:r>
+                        <a:rPr sz="1050" b="0">
+                          <a:solidFill>
+                            <a:srgbClr val="5E7278"/>
+                          </a:solidFill>
+                          <a:latin typeface="Calibri"/>
+                        </a:rPr>
+                        <a:t>LLM08 Vector &amp; Embedding</a:t>
+                      </a:r>
+                    </a:p>
+                  </a:txBody>
+                  <a:tcPr marL="73152" marR="73152" marT="27432" marB="27432" anchor="ctr">
+                    <a:solidFill>
+                      <a:srgbClr val="EEF4F4"/>
+                    </a:solidFill>
+                  </a:tcPr>
+                </a:tc>
+                <a:tc>
+                  <a:txBody>
+                    <a:bodyPr/>
+                    <a:lstStyle/>
+                    <a:p>
+                      <a:pPr algn="l"/>
+                      <a:r>
+                        <a:rPr sz="1050" b="0">
+                          <a:solidFill>
+                            <a:srgbClr val="5E7278"/>
+                          </a:solidFill>
+                          <a:latin typeface="Calibri"/>
+                        </a:rPr>
+                        <a:t>ASI06 Context Poisoning</a:t>
+                      </a:r>
+                    </a:p>
+                  </a:txBody>
+                  <a:tcPr marL="73152" marR="73152" marT="27432" marB="27432" anchor="ctr">
+                    <a:solidFill>
+                      <a:srgbClr val="EEF4F4"/>
+                    </a:solidFill>
+                  </a:tcPr>
+                </a:tc>
+                <a:tc>
+                  <a:txBody>
+                    <a:bodyPr/>
+                    <a:lstStyle/>
+                    <a:p>
+                      <a:pPr algn="l"/>
+                      <a:r>
+                        <a:rPr sz="1050" b="0">
+                          <a:solidFill>
+                            <a:srgbClr val="5E7278"/>
+                          </a:solidFill>
+                          <a:latin typeface="Calibri"/>
+                        </a:rPr>
+                        <a:t/>
+                      </a:r>
+                    </a:p>
+                  </a:txBody>
+                  <a:tcPr marL="73152" marR="73152" marT="27432" marB="27432" anchor="ctr">
+                    <a:solidFill>
+                      <a:srgbClr val="EEF4F4"/>
+                    </a:solidFill>
+                  </a:tcPr>
+                </a:tc>
+              </a:tr>
+              <a:tr h="502920">
+                <a:tc>
+                  <a:txBody>
+                    <a:bodyPr/>
+                    <a:lstStyle/>
+                    <a:p>
+                      <a:pPr algn="l"/>
+                      <a:r>
+                        <a:rPr sz="1050" b="1">
+                          <a:solidFill>
+                            <a:srgbClr val="1B2A30"/>
+                          </a:solidFill>
+                          <a:latin typeface="Calibri"/>
+                        </a:rPr>
+                        <a:t>3  Filters and guardrails</a:t>
+                      </a:r>
+                    </a:p>
+                  </a:txBody>
+                  <a:tcPr marL="73152" marR="73152" marT="27432" marB="27432" anchor="ctr">
+                    <a:solidFill>
+                      <a:srgbClr val="FFFFFF"/>
+                    </a:solidFill>
+                  </a:tcPr>
+                </a:tc>
+                <a:tc>
+                  <a:txBody>
+                    <a:bodyPr/>
+                    <a:lstStyle/>
+                    <a:p>
+                      <a:pPr algn="l"/>
+                      <a:r>
+                        <a:rPr sz="1050" b="0">
+                          <a:solidFill>
+                            <a:srgbClr val="5E7278"/>
+                          </a:solidFill>
+                          <a:latin typeface="Calibri"/>
+                        </a:rPr>
+                        <a:t>LLM01, LLM05</a:t>
+                      </a:r>
+                    </a:p>
+                  </a:txBody>
+                  <a:tcPr marL="73152" marR="73152" marT="27432" marB="27432" anchor="ctr">
+                    <a:solidFill>
+                      <a:srgbClr val="FFFFFF"/>
+                    </a:solidFill>
+                  </a:tcPr>
+                </a:tc>
+                <a:tc>
+                  <a:txBody>
+                    <a:bodyPr/>
+                    <a:lstStyle/>
+                    <a:p>
+                      <a:pPr algn="l"/>
+                      <a:r>
+                        <a:rPr sz="1050" b="0">
+                          <a:solidFill>
+                            <a:srgbClr val="5E7278"/>
+                          </a:solidFill>
+                          <a:latin typeface="Calibri"/>
+                        </a:rPr>
+                        <a:t/>
+                      </a:r>
+                    </a:p>
+                  </a:txBody>
+                  <a:tcPr marL="73152" marR="73152" marT="27432" marB="27432" anchor="ctr">
+                    <a:solidFill>
+                      <a:srgbClr val="FFFFFF"/>
+                    </a:solidFill>
+                  </a:tcPr>
+                </a:tc>
+                <a:tc>
+                  <a:txBody>
+                    <a:bodyPr/>
+                    <a:lstStyle/>
+                    <a:p>
+                      <a:pPr algn="l"/>
+                      <a:r>
+                        <a:rPr sz="1050" b="0">
+                          <a:solidFill>
+                            <a:srgbClr val="5E7278"/>
+                          </a:solidFill>
+                          <a:latin typeface="Calibri"/>
+                        </a:rPr>
+                        <a:t/>
+                      </a:r>
+                    </a:p>
+                  </a:txBody>
+                  <a:tcPr marL="73152" marR="73152" marT="27432" marB="27432" anchor="ctr">
+                    <a:solidFill>
+                      <a:srgbClr val="FFFFFF"/>
+                    </a:solidFill>
+                  </a:tcPr>
+                </a:tc>
+              </a:tr>
+              <a:tr h="502920">
+                <a:tc>
+                  <a:txBody>
+                    <a:bodyPr/>
+                    <a:lstStyle/>
+                    <a:p>
+                      <a:pPr algn="l"/>
+                      <a:r>
+                        <a:rPr sz="1050" b="1">
+                          <a:solidFill>
+                            <a:srgbClr val="1B2A30"/>
+                          </a:solidFill>
+                          <a:latin typeface="Calibri"/>
+                        </a:rPr>
+                        <a:t>4  Tools and permissions</a:t>
+                      </a:r>
+                    </a:p>
+                  </a:txBody>
+                  <a:tcPr marL="73152" marR="73152" marT="27432" marB="27432" anchor="ctr">
+                    <a:solidFill>
+                      <a:srgbClr val="EEF4F4"/>
+                    </a:solidFill>
+                  </a:tcPr>
+                </a:tc>
+                <a:tc>
+                  <a:txBody>
+                    <a:bodyPr/>
+                    <a:lstStyle/>
+                    <a:p>
+                      <a:pPr algn="l"/>
+                      <a:r>
+                        <a:rPr sz="1050" b="0">
+                          <a:solidFill>
+                            <a:srgbClr val="5E7278"/>
+                          </a:solidFill>
+                          <a:latin typeface="Calibri"/>
+                        </a:rPr>
+                        <a:t>LLM06 Excessive Agency</a:t>
+                      </a:r>
+                    </a:p>
+                  </a:txBody>
+                  <a:tcPr marL="73152" marR="73152" marT="27432" marB="27432" anchor="ctr">
+                    <a:solidFill>
+                      <a:srgbClr val="EEF4F4"/>
+                    </a:solidFill>
+                  </a:tcPr>
+                </a:tc>
+                <a:tc>
+                  <a:txBody>
+                    <a:bodyPr/>
+                    <a:lstStyle/>
+                    <a:p>
+                      <a:pPr algn="l"/>
+                      <a:r>
+                        <a:rPr sz="1050" b="0">
+                          <a:solidFill>
+                            <a:srgbClr val="5E7278"/>
+                          </a:solidFill>
+                          <a:latin typeface="Calibri"/>
+                        </a:rPr>
+                        <a:t>ASI02 Tool Misuse, ASI03 Privilege Abuse</a:t>
+                      </a:r>
+                    </a:p>
+                  </a:txBody>
+                  <a:tcPr marL="73152" marR="73152" marT="27432" marB="27432" anchor="ctr">
+                    <a:solidFill>
+                      <a:srgbClr val="EEF4F4"/>
+                    </a:solidFill>
+                  </a:tcPr>
+                </a:tc>
+                <a:tc>
+                  <a:txBody>
+                    <a:bodyPr/>
+                    <a:lstStyle/>
+                    <a:p>
+                      <a:pPr algn="l"/>
+                      <a:r>
+                        <a:rPr sz="1050" b="0">
+                          <a:solidFill>
+                            <a:srgbClr val="5E7278"/>
+                          </a:solidFill>
+                          <a:latin typeface="Calibri"/>
+                        </a:rPr>
+                        <a:t/>
+                      </a:r>
+                    </a:p>
+                  </a:txBody>
+                  <a:tcPr marL="73152" marR="73152" marT="27432" marB="27432" anchor="ctr">
+                    <a:solidFill>
+                      <a:srgbClr val="EEF4F4"/>
+                    </a:solidFill>
+                  </a:tcPr>
+                </a:tc>
+              </a:tr>
+              <a:tr h="502920">
+                <a:tc>
+                  <a:txBody>
+                    <a:bodyPr/>
+                    <a:lstStyle/>
+                    <a:p>
+                      <a:pPr algn="l"/>
+                      <a:r>
+                        <a:rPr sz="1050" b="1">
+                          <a:solidFill>
+                            <a:srgbClr val="1B2A30"/>
+                          </a:solidFill>
+                          <a:latin typeface="Calibri"/>
+                        </a:rPr>
+                        <a:t>5  Isolated code execution</a:t>
+                      </a:r>
+                    </a:p>
+                  </a:txBody>
+                  <a:tcPr marL="73152" marR="73152" marT="27432" marB="27432" anchor="ctr">
+                    <a:solidFill>
+                      <a:srgbClr val="FFFFFF"/>
+                    </a:solidFill>
+                  </a:tcPr>
+                </a:tc>
+                <a:tc>
+                  <a:txBody>
+                    <a:bodyPr/>
+                    <a:lstStyle/>
+                    <a:p>
+                      <a:pPr algn="l"/>
+                      <a:r>
+                        <a:rPr sz="1050" b="0">
+                          <a:solidFill>
+                            <a:srgbClr val="5E7278"/>
+                          </a:solidFill>
+                          <a:latin typeface="Calibri"/>
+                        </a:rPr>
+                        <a:t/>
+                      </a:r>
+                    </a:p>
+                  </a:txBody>
+                  <a:tcPr marL="73152" marR="73152" marT="27432" marB="27432" anchor="ctr">
+                    <a:solidFill>
+                      <a:srgbClr val="FFFFFF"/>
+                    </a:solidFill>
+                  </a:tcPr>
+                </a:tc>
+                <a:tc>
+                  <a:txBody>
+                    <a:bodyPr/>
+                    <a:lstStyle/>
+                    <a:p>
+                      <a:pPr algn="l"/>
+                      <a:r>
+                        <a:rPr sz="1050" b="0">
+                          <a:solidFill>
+                            <a:srgbClr val="5E7278"/>
+                          </a:solidFill>
+                          <a:latin typeface="Calibri"/>
+                        </a:rPr>
+                        <a:t>ASI05 Unexpected Code Execution</a:t>
+                      </a:r>
+                    </a:p>
+                  </a:txBody>
+                  <a:tcPr marL="73152" marR="73152" marT="27432" marB="27432" anchor="ctr">
+                    <a:solidFill>
+                      <a:srgbClr val="FFFFFF"/>
+                    </a:solidFill>
+                  </a:tcPr>
+                </a:tc>
+                <a:tc>
+                  <a:txBody>
+                    <a:bodyPr/>
+                    <a:lstStyle/>
+                    <a:p>
+                      <a:pPr algn="l"/>
+                      <a:r>
+                        <a:rPr sz="1050" b="0">
+                          <a:solidFill>
+                            <a:srgbClr val="5E7278"/>
+                          </a:solidFill>
+                          <a:latin typeface="Calibri"/>
+                        </a:rPr>
+                        <a:t/>
+                      </a:r>
+                    </a:p>
+                  </a:txBody>
+                  <a:tcPr marL="73152" marR="73152" marT="27432" marB="27432" anchor="ctr">
+                    <a:solidFill>
+                      <a:srgbClr val="FFFFFF"/>
+                    </a:solidFill>
+                  </a:tcPr>
+                </a:tc>
+              </a:tr>
+              <a:tr h="502920">
+                <a:tc>
+                  <a:txBody>
+                    <a:bodyPr/>
+                    <a:lstStyle/>
+                    <a:p>
+                      <a:pPr algn="l"/>
+                      <a:r>
+                        <a:rPr sz="1050" b="1">
+                          <a:solidFill>
+                            <a:srgbClr val="1B2A30"/>
+                          </a:solidFill>
+                          <a:latin typeface="Calibri"/>
+                        </a:rPr>
+                        <a:t>6  Memory and persistence</a:t>
+                      </a:r>
+                    </a:p>
+                  </a:txBody>
+                  <a:tcPr marL="73152" marR="73152" marT="27432" marB="27432" anchor="ctr">
+                    <a:solidFill>
+                      <a:srgbClr val="EEF4F4"/>
+                    </a:solidFill>
+                  </a:tcPr>
+                </a:tc>
+                <a:tc>
+                  <a:txBody>
+                    <a:bodyPr/>
+                    <a:lstStyle/>
+                    <a:p>
+                      <a:pPr algn="l"/>
+                      <a:r>
+                        <a:rPr sz="1050" b="0">
+                          <a:solidFill>
+                            <a:srgbClr val="5E7278"/>
+                          </a:solidFill>
+                          <a:latin typeface="Calibri"/>
+                        </a:rPr>
+                        <a:t/>
+                      </a:r>
+                    </a:p>
+                  </a:txBody>
+                  <a:tcPr marL="73152" marR="73152" marT="27432" marB="27432" anchor="ctr">
+                    <a:solidFill>
+                      <a:srgbClr val="EEF4F4"/>
+                    </a:solidFill>
+                  </a:tcPr>
+                </a:tc>
+                <a:tc>
+                  <a:txBody>
+                    <a:bodyPr/>
+                    <a:lstStyle/>
+                    <a:p>
+                      <a:pPr algn="l"/>
+                      <a:r>
+                        <a:rPr sz="1050" b="0">
+                          <a:solidFill>
+                            <a:srgbClr val="5E7278"/>
+                          </a:solidFill>
+                          <a:latin typeface="Calibri"/>
+                        </a:rPr>
+                        <a:t>ASI06 Memory &amp; Context Poisoning</a:t>
+                      </a:r>
+                    </a:p>
+                  </a:txBody>
+                  <a:tcPr marL="73152" marR="73152" marT="27432" marB="27432" anchor="ctr">
+                    <a:solidFill>
+                      <a:srgbClr val="EEF4F4"/>
+                    </a:solidFill>
+                  </a:tcPr>
+                </a:tc>
+                <a:tc>
+                  <a:txBody>
+                    <a:bodyPr/>
+                    <a:lstStyle/>
+                    <a:p>
+                      <a:pPr algn="l"/>
+                      <a:r>
+                        <a:rPr sz="1050" b="0">
+                          <a:solidFill>
+                            <a:srgbClr val="5E7278"/>
+                          </a:solidFill>
+                          <a:latin typeface="Calibri"/>
+                        </a:rPr>
+                        <a:t/>
+                      </a:r>
+                    </a:p>
+                  </a:txBody>
+                  <a:tcPr marL="73152" marR="73152" marT="27432" marB="27432" anchor="ctr">
+                    <a:solidFill>
+                      <a:srgbClr val="EEF4F4"/>
+                    </a:solidFill>
+                  </a:tcPr>
+                </a:tc>
+              </a:tr>
+              <a:tr h="502920">
+                <a:tc>
+                  <a:txBody>
+                    <a:bodyPr/>
+                    <a:lstStyle/>
+                    <a:p>
+                      <a:pPr algn="l"/>
+                      <a:r>
+                        <a:rPr sz="1050" b="1">
+                          <a:solidFill>
+                            <a:srgbClr val="1B2A30"/>
+                          </a:solidFill>
+                          <a:latin typeface="Calibri"/>
+                        </a:rPr>
+                        <a:t>7  Data protection</a:t>
+                      </a:r>
+                    </a:p>
+                  </a:txBody>
+                  <a:tcPr marL="73152" marR="73152" marT="27432" marB="27432" anchor="ctr">
+                    <a:solidFill>
+                      <a:srgbClr val="FFFFFF"/>
+                    </a:solidFill>
+                  </a:tcPr>
+                </a:tc>
+                <a:tc>
+                  <a:txBody>
+                    <a:bodyPr/>
+                    <a:lstStyle/>
+                    <a:p>
+                      <a:pPr algn="l"/>
+                      <a:r>
+                        <a:rPr sz="1050" b="0">
+                          <a:solidFill>
+                            <a:srgbClr val="5E7278"/>
+                          </a:solidFill>
+                          <a:latin typeface="Calibri"/>
+                        </a:rPr>
+                        <a:t>LLM02 Sensitive Info Disclosure</a:t>
+                      </a:r>
+                    </a:p>
+                  </a:txBody>
+                  <a:tcPr marL="73152" marR="73152" marT="27432" marB="27432" anchor="ctr">
+                    <a:solidFill>
+                      <a:srgbClr val="FFFFFF"/>
+                    </a:solidFill>
+                  </a:tcPr>
+                </a:tc>
+                <a:tc>
+                  <a:txBody>
+                    <a:bodyPr/>
+                    <a:lstStyle/>
+                    <a:p>
+                      <a:pPr algn="l"/>
+                      <a:r>
+                        <a:rPr sz="1050" b="0">
+                          <a:solidFill>
+                            <a:srgbClr val="5E7278"/>
+                          </a:solidFill>
+                          <a:latin typeface="Calibri"/>
+                        </a:rPr>
+                        <a:t/>
+                      </a:r>
+                    </a:p>
+                  </a:txBody>
+                  <a:tcPr marL="73152" marR="73152" marT="27432" marB="27432" anchor="ctr">
+                    <a:solidFill>
+                      <a:srgbClr val="FFFFFF"/>
+                    </a:solidFill>
+                  </a:tcPr>
+                </a:tc>
+                <a:tc>
+                  <a:txBody>
+                    <a:bodyPr/>
+                    <a:lstStyle/>
+                    <a:p>
+                      <a:pPr algn="l"/>
+                      <a:r>
+                        <a:rPr sz="1050" b="0">
+                          <a:solidFill>
+                            <a:srgbClr val="5E7278"/>
+                          </a:solidFill>
+                          <a:latin typeface="Calibri"/>
+                        </a:rPr>
+                        <a:t>GDPR, AI Act Art. 10</a:t>
+                      </a:r>
+                    </a:p>
+                  </a:txBody>
+                  <a:tcPr marL="73152" marR="73152" marT="27432" marB="27432" anchor="ctr">
+                    <a:solidFill>
+                      <a:srgbClr val="FFFFFF"/>
+                    </a:solidFill>
+                  </a:tcPr>
+                </a:tc>
+              </a:tr>
+              <a:tr h="502920">
+                <a:tc>
+                  <a:txBody>
+                    <a:bodyPr/>
+                    <a:lstStyle/>
+                    <a:p>
+                      <a:pPr algn="l"/>
+                      <a:r>
+                        <a:rPr sz="1050" b="1">
+                          <a:solidFill>
+                            <a:srgbClr val="1B2A30"/>
+                          </a:solidFill>
+                          <a:latin typeface="Calibri"/>
+                        </a:rPr>
+                        <a:t>8  Monitoring &amp; governance</a:t>
+                      </a:r>
+                    </a:p>
+                  </a:txBody>
+                  <a:tcPr marL="73152" marR="73152" marT="27432" marB="27432" anchor="ctr">
+                    <a:solidFill>
+                      <a:srgbClr val="EEF4F4"/>
+                    </a:solidFill>
+                  </a:tcPr>
+                </a:tc>
+                <a:tc>
+                  <a:txBody>
+                    <a:bodyPr/>
+                    <a:lstStyle/>
+                    <a:p>
+                      <a:pPr algn="l"/>
+                      <a:r>
+                        <a:rPr sz="1050" b="0">
+                          <a:solidFill>
+                            <a:srgbClr val="5E7278"/>
+                          </a:solidFill>
+                          <a:latin typeface="Calibri"/>
+                        </a:rPr>
+                        <a:t/>
+                      </a:r>
+                    </a:p>
+                  </a:txBody>
+                  <a:tcPr marL="73152" marR="73152" marT="27432" marB="27432" anchor="ctr">
+                    <a:solidFill>
+                      <a:srgbClr val="EEF4F4"/>
+                    </a:solidFill>
+                  </a:tcPr>
+                </a:tc>
+                <a:tc>
+                  <a:txBody>
+                    <a:bodyPr/>
+                    <a:lstStyle/>
+                    <a:p>
+                      <a:pPr algn="l"/>
+                      <a:r>
+                        <a:rPr sz="1050" b="0">
+                          <a:solidFill>
+                            <a:srgbClr val="5E7278"/>
+                          </a:solidFill>
+                          <a:latin typeface="Calibri"/>
+                        </a:rPr>
+                        <a:t>ASI08 Cascading, ASI10 Rogue Agents</a:t>
+                      </a:r>
+                    </a:p>
+                  </a:txBody>
+                  <a:tcPr marL="73152" marR="73152" marT="27432" marB="27432" anchor="ctr">
+                    <a:solidFill>
+                      <a:srgbClr val="EEF4F4"/>
+                    </a:solidFill>
+                  </a:tcPr>
+                </a:tc>
+                <a:tc>
+                  <a:txBody>
+                    <a:bodyPr/>
+                    <a:lstStyle/>
+                    <a:p>
+                      <a:pPr algn="l"/>
+                      <a:r>
+                        <a:rPr sz="1050" b="0">
+                          <a:solidFill>
+                            <a:srgbClr val="5E7278"/>
+                          </a:solidFill>
+                          <a:latin typeface="Calibri"/>
+                        </a:rPr>
+                        <a:t>NIST AI RMF, AI Act Art. 9-15</a:t>
+                      </a:r>
+                    </a:p>
+                  </a:txBody>
+                  <a:tcPr marL="73152" marR="73152" marT="27432" marB="27432" anchor="ctr">
+                    <a:solidFill>
+                      <a:srgbClr val="EEF4F4"/>
+                    </a:solidFill>
+                  </a:tcPr>
+                </a:tc>
+              </a:tr>
+            </a:tbl>
+          </a:graphicData>
+        </a:graphic>
+      </p:graphicFrame>
+      <p:sp>
+        <p:nvSpPr>
+          <p:cNvPr id="7" name="TextBox 6"/>
           <p:cNvSpPr txBox="1"/>
           <p:nvPr/>
         </p:nvSpPr>
         <p:spPr>
           <a:xfrm>
-            <a:off x="548640" y="1554480"/>
-            <a:ext cx="11094415" cy="365760"/>
+            <a:off x="548640" y="5943600"/>
+            <a:ext cx="11094415" cy="457200"/>
           </a:xfrm>
           <a:prstGeom prst="rect">
             <a:avLst/>
@@ -8960,280 +10188,25 @@
           <a:p>
             <a:pPr algn="l"/>
             <a:r>
-              <a:rPr sz="1600" b="0" i="0">
+              <a:rPr sz="1150" b="0" i="0">
                 <a:solidFill>
-                  <a:srgbClr val="1B2A30"/>
+                  <a:srgbClr val="1F6F78"/>
                 </a:solidFill>
                 <a:latin typeface="Calibri"/>
               </a:rPr>
-              <a:t>It fits two work packages directly:</a:t>
-            </a:r>
-          </a:p>
-        </p:txBody>
-      </p:sp>
-      <p:sp>
-        <p:nvSpPr>
-          <p:cNvPr id="7" name="Rounded Rectangle 6"/>
-          <p:cNvSpPr/>
-          <p:nvPr/>
-        </p:nvSpPr>
-        <p:spPr>
-          <a:xfrm>
-            <a:off x="548640" y="2194560"/>
-            <a:ext cx="5318607" cy="1920240"/>
-          </a:xfrm>
-          <a:prstGeom prst="roundRect">
-            <a:avLst/>
-          </a:prstGeom>
-          <a:solidFill>
-            <a:srgbClr val="13262F"/>
-          </a:solidFill>
-          <a:ln w="12700">
-            <a:solidFill>
-              <a:srgbClr val="13262F"/>
-            </a:solidFill>
-          </a:ln>
-          <a:effectLst/>
-        </p:spPr>
-        <p:style>
-          <a:lnRef idx="1">
-            <a:schemeClr val="accent1"/>
-          </a:lnRef>
-          <a:fillRef idx="3">
-            <a:schemeClr val="accent1"/>
-          </a:fillRef>
-          <a:effectRef idx="2">
-            <a:schemeClr val="accent1"/>
-          </a:effectRef>
-          <a:fontRef idx="minor">
-            <a:schemeClr val="lt1"/>
-          </a:fontRef>
-        </p:style>
-        <p:txBody>
-          <a:bodyPr rtlCol="0" anchor="ctr"/>
-          <a:lstStyle/>
-          <a:p>
-            <a:pPr algn="ctr"/>
-          </a:p>
-        </p:txBody>
-      </p:sp>
-      <p:sp>
-        <p:nvSpPr>
-          <p:cNvPr id="8" name="TextBox 7"/>
-          <p:cNvSpPr txBox="1"/>
-          <p:nvPr/>
-        </p:nvSpPr>
-        <p:spPr>
-          <a:xfrm>
-            <a:off x="868680" y="2423160"/>
-            <a:ext cx="4678527" cy="457200"/>
-          </a:xfrm>
-          <a:prstGeom prst="rect">
-            <a:avLst/>
-          </a:prstGeom>
-          <a:noFill/>
-        </p:spPr>
-        <p:txBody>
-          <a:bodyPr wrap="square" anchor="t" lIns="0" rIns="0" tIns="0" bIns="0">
-            <a:spAutoFit/>
-          </a:bodyPr>
-          <a:lstStyle/>
+              <a:t>Risks span both the LLM (the model) and the agent (the system around it); the fixes always sit in the agent, not the model.</a:t>
+            </a:r>
+          </a:p>
           <a:p>
             <a:pPr algn="l"/>
             <a:r>
-              <a:rPr sz="2200" b="1" i="0">
-                <a:solidFill>
-                  <a:srgbClr val="F2A541"/>
-                </a:solidFill>
-                <a:latin typeface="Cambria"/>
-              </a:rPr>
-              <a:t>WP3 · T3.1</a:t>
-            </a:r>
-          </a:p>
-        </p:txBody>
-      </p:sp>
-      <p:sp>
-        <p:nvSpPr>
-          <p:cNvPr id="9" name="TextBox 8"/>
-          <p:cNvSpPr txBox="1"/>
-          <p:nvPr/>
-        </p:nvSpPr>
-        <p:spPr>
-          <a:xfrm>
-            <a:off x="868680" y="2971800"/>
-            <a:ext cx="4678527" cy="1005840"/>
-          </a:xfrm>
-          <a:prstGeom prst="rect">
-            <a:avLst/>
-          </a:prstGeom>
-          <a:noFill/>
-        </p:spPr>
-        <p:txBody>
-          <a:bodyPr wrap="square" anchor="t" lIns="0" rIns="0" tIns="0" bIns="0">
-            <a:spAutoFit/>
-          </a:bodyPr>
-          <a:lstStyle/>
-          <a:p>
-            <a:pPr algn="l"/>
-            <a:r>
-              <a:rPr sz="1500" b="0" i="0">
-                <a:solidFill>
-                  <a:srgbClr val="FFFFFF"/>
-                </a:solidFill>
-                <a:latin typeface="Calibri"/>
-              </a:rPr>
-              <a:t>The lab is the “sandboxed emulator” the task asks for, and the pack ends in the conformity / ethics self-assessment.</a:t>
-            </a:r>
-          </a:p>
-        </p:txBody>
-      </p:sp>
-      <p:sp>
-        <p:nvSpPr>
-          <p:cNvPr id="10" name="Rounded Rectangle 9"/>
-          <p:cNvSpPr/>
-          <p:nvPr/>
-        </p:nvSpPr>
-        <p:spPr>
-          <a:xfrm>
-            <a:off x="6324447" y="2194560"/>
-            <a:ext cx="5318607" cy="1920240"/>
-          </a:xfrm>
-          <a:prstGeom prst="roundRect">
-            <a:avLst/>
-          </a:prstGeom>
-          <a:solidFill>
-            <a:srgbClr val="13262F"/>
-          </a:solidFill>
-          <a:ln w="12700">
-            <a:solidFill>
-              <a:srgbClr val="13262F"/>
-            </a:solidFill>
-          </a:ln>
-          <a:effectLst/>
-        </p:spPr>
-        <p:style>
-          <a:lnRef idx="1">
-            <a:schemeClr val="accent1"/>
-          </a:lnRef>
-          <a:fillRef idx="3">
-            <a:schemeClr val="accent1"/>
-          </a:fillRef>
-          <a:effectRef idx="2">
-            <a:schemeClr val="accent1"/>
-          </a:effectRef>
-          <a:fontRef idx="minor">
-            <a:schemeClr val="lt1"/>
-          </a:fontRef>
-        </p:style>
-        <p:txBody>
-          <a:bodyPr rtlCol="0" anchor="ctr"/>
-          <a:lstStyle/>
-          <a:p>
-            <a:pPr algn="ctr"/>
-          </a:p>
-        </p:txBody>
-      </p:sp>
-      <p:sp>
-        <p:nvSpPr>
-          <p:cNvPr id="11" name="TextBox 10"/>
-          <p:cNvSpPr txBox="1"/>
-          <p:nvPr/>
-        </p:nvSpPr>
-        <p:spPr>
-          <a:xfrm>
-            <a:off x="6644487" y="2423160"/>
-            <a:ext cx="4678527" cy="457200"/>
-          </a:xfrm>
-          <a:prstGeom prst="rect">
-            <a:avLst/>
-          </a:prstGeom>
-          <a:noFill/>
-        </p:spPr>
-        <p:txBody>
-          <a:bodyPr wrap="square" anchor="t" lIns="0" rIns="0" tIns="0" bIns="0">
-            <a:spAutoFit/>
-          </a:bodyPr>
-          <a:lstStyle/>
-          <a:p>
-            <a:pPr algn="l"/>
-            <a:r>
-              <a:rPr sz="2200" b="1" i="0">
-                <a:solidFill>
-                  <a:srgbClr val="F2A541"/>
-                </a:solidFill>
-                <a:latin typeface="Cambria"/>
-              </a:rPr>
-              <a:t>WP7 · T7.3</a:t>
-            </a:r>
-          </a:p>
-        </p:txBody>
-      </p:sp>
-      <p:sp>
-        <p:nvSpPr>
-          <p:cNvPr id="12" name="TextBox 11"/>
-          <p:cNvSpPr txBox="1"/>
-          <p:nvPr/>
-        </p:nvSpPr>
-        <p:spPr>
-          <a:xfrm>
-            <a:off x="6644487" y="2971800"/>
-            <a:ext cx="4678527" cy="1005840"/>
-          </a:xfrm>
-          <a:prstGeom prst="rect">
-            <a:avLst/>
-          </a:prstGeom>
-          <a:noFill/>
-        </p:spPr>
-        <p:txBody>
-          <a:bodyPr wrap="square" anchor="t" lIns="0" rIns="0" tIns="0" bIns="0">
-            <a:spAutoFit/>
-          </a:bodyPr>
-          <a:lstStyle/>
-          <a:p>
-            <a:pPr algn="l"/>
-            <a:r>
-              <a:rPr sz="1500" b="0" i="0">
-                <a:solidFill>
-                  <a:srgbClr val="FFFFFF"/>
-                </a:solidFill>
-                <a:latin typeface="Calibri"/>
-              </a:rPr>
-              <a:t>Modular, hands-on LLM training for the three audiences the task names.</a:t>
-            </a:r>
-          </a:p>
-        </p:txBody>
-      </p:sp>
-      <p:sp>
-        <p:nvSpPr>
-          <p:cNvPr id="13" name="TextBox 12"/>
-          <p:cNvSpPr txBox="1"/>
-          <p:nvPr/>
-        </p:nvSpPr>
-        <p:spPr>
-          <a:xfrm>
-            <a:off x="548640" y="4480560"/>
-            <a:ext cx="11094415" cy="548640"/>
-          </a:xfrm>
-          <a:prstGeom prst="rect">
-            <a:avLst/>
-          </a:prstGeom>
-          <a:noFill/>
-        </p:spPr>
-        <p:txBody>
-          <a:bodyPr wrap="square" anchor="t" lIns="0" rIns="0" tIns="0" bIns="0">
-            <a:spAutoFit/>
-          </a:bodyPr>
-          <a:lstStyle/>
-          <a:p>
-            <a:pPr algn="l"/>
-            <a:r>
-              <a:rPr sz="1300" b="0" i="1">
+              <a:rPr sz="1100" b="0" i="1">
                 <a:solidFill>
                   <a:srgbClr val="5E7278"/>
                 </a:solidFill>
                 <a:latin typeface="Calibri"/>
               </a:rPr>
-              <a:t>Other WP3/WP7 tasks (data access, secure environments, the Training Hub repository, guest lectures) are touched by specific notebooks: detail on request.</a:t>
+              <a:t>Backup for the T3.1 conformity mapping. Hidden by default; shown only if asked.</a:t>
             </a:r>
           </a:p>
         </p:txBody>
@@ -9564,4 +10537,324 @@
   </a:objectDefaults>
   <a:extraClrSchemeLst/>
 </a:theme>
+</file>
+
+<file path=ppt/theme/theme2.xml><?xml version="1.0" encoding="utf-8"?>
+<a:theme xmlns:a="http://schemas.openxmlformats.org/drawingml/2006/main" name="Office Theme">
+  <a:themeElements>
+    <a:clrScheme name="Office">
+      <a:dk1>
+        <a:sysClr val="windowText" lastClr="000000"/>
+      </a:dk1>
+      <a:lt1>
+        <a:sysClr val="window" lastClr="FFFFFF"/>
+      </a:lt1>
+      <a:dk2>
+        <a:srgbClr val="1F497D"/>
+      </a:dk2>
+      <a:lt2>
+        <a:srgbClr val="EEECE1"/>
+      </a:lt2>
+      <a:accent1>
+        <a:srgbClr val="4F81BD"/>
+      </a:accent1>
+      <a:accent2>
+        <a:srgbClr val="C0504D"/>
+      </a:accent2>
+      <a:accent3>
+        <a:srgbClr val="9BBB59"/>
+      </a:accent3>
+      <a:accent4>
+        <a:srgbClr val="8064A2"/>
+      </a:accent4>
+      <a:accent5>
+        <a:srgbClr val="4BACC6"/>
+      </a:accent5>
+      <a:accent6>
+        <a:srgbClr val="F79646"/>
+      </a:accent6>
+      <a:hlink>
+        <a:srgbClr val="0000FF"/>
+      </a:hlink>
+      <a:folHlink>
+        <a:srgbClr val="800080"/>
+      </a:folHlink>
+    </a:clrScheme>
+    <a:fontScheme name="Office">
+      <a:majorFont>
+        <a:latin typeface="Calibri"/>
+        <a:ea typeface=""/>
+        <a:cs typeface=""/>
+        <a:font script="Jpan" typeface="ＭＳ Ｐゴシック"/>
+        <a:font script="Hang" typeface="맑은 고딕"/>
+        <a:font script="Hans" typeface="宋体"/>
+        <a:font script="Hant" typeface="新細明體"/>
+        <a:font script="Arab" typeface="Times New Roman"/>
+        <a:font script="Hebr" typeface="Times New Roman"/>
+        <a:font script="Thai" typeface="Angsana New"/>
+        <a:font script="Ethi" typeface="Nyala"/>
+        <a:font script="Beng" typeface="Vrinda"/>
+        <a:font script="Gujr" typeface="Shruti"/>
+        <a:font script="Khmr" typeface="MoolBoran"/>
+        <a:font script="Knda" typeface="Tunga"/>
+        <a:font script="Guru" typeface="Raavi"/>
+        <a:font script="Cans" typeface="Euphemia"/>
+        <a:font script="Cher" typeface="Plantagenet Cherokee"/>
+        <a:font script="Yiii" typeface="Microsoft Yi Baiti"/>
+        <a:font script="Tibt" typeface="Microsoft Himalaya"/>
+        <a:font script="Thaa" typeface="MV Boli"/>
+        <a:font script="Deva" typeface="Mangal"/>
+        <a:font script="Telu" typeface="Gautami"/>
+        <a:font script="Taml" typeface="Latha"/>
+        <a:font script="Syrc" typeface="Estrangelo Edessa"/>
+        <a:font script="Orya" typeface="Kalinga"/>
+        <a:font script="Mlym" typeface="Kartika"/>
+        <a:font script="Laoo" typeface="DokChampa"/>
+        <a:font script="Sinh" typeface="Iskoola Pota"/>
+        <a:font script="Mong" typeface="Mongolian Baiti"/>
+        <a:font script="Viet" typeface="Times New Roman"/>
+        <a:font script="Uigh" typeface="Microsoft Uighur"/>
+        <a:font script="Geor" typeface="Sylfaen"/>
+      </a:majorFont>
+      <a:minorFont>
+        <a:latin typeface="Calibri"/>
+        <a:ea typeface=""/>
+        <a:cs typeface=""/>
+        <a:font script="Jpan" typeface="ＭＳ Ｐゴシック"/>
+        <a:font script="Hang" typeface="맑은 고딕"/>
+        <a:font script="Hans" typeface="宋体"/>
+        <a:font script="Hant" typeface="新細明體"/>
+        <a:font script="Arab" typeface="Arial"/>
+        <a:font script="Hebr" typeface="Arial"/>
+        <a:font script="Thai" typeface="Cordia New"/>
+        <a:font script="Ethi" typeface="Nyala"/>
+        <a:font script="Beng" typeface="Vrinda"/>
+        <a:font script="Gujr" typeface="Shruti"/>
+        <a:font script="Khmr" typeface="DaunPenh"/>
+        <a:font script="Knda" typeface="Tunga"/>
+        <a:font script="Guru" typeface="Raavi"/>
+        <a:font script="Cans" typeface="Euphemia"/>
+        <a:font script="Cher" typeface="Plantagenet Cherokee"/>
+        <a:font script="Yiii" typeface="Microsoft Yi Baiti"/>
+        <a:font script="Tibt" typeface="Microsoft Himalaya"/>
+        <a:font script="Thaa" typeface="MV Boli"/>
+        <a:font script="Deva" typeface="Mangal"/>
+        <a:font script="Telu" typeface="Gautami"/>
+        <a:font script="Taml" typeface="Latha"/>
+        <a:font script="Syrc" typeface="Estrangelo Edessa"/>
+        <a:font script="Orya" typeface="Kalinga"/>
+        <a:font script="Mlym" typeface="Kartika"/>
+        <a:font script="Laoo" typeface="DokChampa"/>
+        <a:font script="Sinh" typeface="Iskoola Pota"/>
+        <a:font script="Mong" typeface="Mongolian Baiti"/>
+        <a:font script="Viet" typeface="Arial"/>
+        <a:font script="Uigh" typeface="Microsoft Uighur"/>
+        <a:font script="Geor" typeface="Sylfaen"/>
+      </a:minorFont>
+    </a:fontScheme>
+    <a:fmtScheme name="Office">
+      <a:fillStyleLst>
+        <a:solidFill>
+          <a:schemeClr val="phClr"/>
+        </a:solidFill>
+        <a:gradFill rotWithShape="1">
+          <a:gsLst>
+            <a:gs pos="0">
+              <a:schemeClr val="phClr">
+                <a:tint val="50000"/>
+                <a:satMod val="300000"/>
+              </a:schemeClr>
+            </a:gs>
+            <a:gs pos="35000">
+              <a:schemeClr val="phClr">
+                <a:tint val="37000"/>
+                <a:satMod val="300000"/>
+              </a:schemeClr>
+            </a:gs>
+            <a:gs pos="100000">
+              <a:schemeClr val="phClr">
+                <a:tint val="15000"/>
+                <a:satMod val="350000"/>
+              </a:schemeClr>
+            </a:gs>
+          </a:gsLst>
+          <a:lin ang="16200000" scaled="1"/>
+        </a:gradFill>
+        <a:gradFill rotWithShape="1">
+          <a:gsLst>
+            <a:gs pos="0">
+              <a:schemeClr val="phClr">
+                <a:tint val="100000"/>
+                <a:shade val="100000"/>
+                <a:satMod val="130000"/>
+              </a:schemeClr>
+            </a:gs>
+            <a:gs pos="100000">
+              <a:schemeClr val="phClr">
+                <a:tint val="50000"/>
+                <a:shade val="100000"/>
+                <a:satMod val="350000"/>
+              </a:schemeClr>
+            </a:gs>
+          </a:gsLst>
+          <a:lin ang="16200000" scaled="0"/>
+        </a:gradFill>
+      </a:fillStyleLst>
+      <a:lnStyleLst>
+        <a:ln w="9525" cap="flat" cmpd="sng" algn="ctr">
+          <a:solidFill>
+            <a:schemeClr val="phClr">
+              <a:shade val="95000"/>
+              <a:satMod val="105000"/>
+            </a:schemeClr>
+          </a:solidFill>
+          <a:prstDash val="solid"/>
+        </a:ln>
+        <a:ln w="25400" cap="flat" cmpd="sng" algn="ctr">
+          <a:solidFill>
+            <a:schemeClr val="phClr"/>
+          </a:solidFill>
+          <a:prstDash val="solid"/>
+        </a:ln>
+        <a:ln w="38100" cap="flat" cmpd="sng" algn="ctr">
+          <a:solidFill>
+            <a:schemeClr val="phClr"/>
+          </a:solidFill>
+          <a:prstDash val="solid"/>
+        </a:ln>
+      </a:lnStyleLst>
+      <a:effectStyleLst>
+        <a:effectStyle>
+          <a:effectLst>
+            <a:outerShdw blurRad="40000" dist="20000" dir="5400000" rotWithShape="0">
+              <a:srgbClr val="000000">
+                <a:alpha val="38000"/>
+              </a:srgbClr>
+            </a:outerShdw>
+          </a:effectLst>
+        </a:effectStyle>
+        <a:effectStyle>
+          <a:effectLst>
+            <a:outerShdw blurRad="40000" dist="23000" dir="5400000" rotWithShape="0">
+              <a:srgbClr val="000000">
+                <a:alpha val="35000"/>
+              </a:srgbClr>
+            </a:outerShdw>
+          </a:effectLst>
+        </a:effectStyle>
+        <a:effectStyle>
+          <a:effectLst>
+            <a:outerShdw blurRad="40000" dist="23000" dir="5400000" rotWithShape="0">
+              <a:srgbClr val="000000">
+                <a:alpha val="35000"/>
+              </a:srgbClr>
+            </a:outerShdw>
+          </a:effectLst>
+          <a:scene3d>
+            <a:camera prst="orthographicFront">
+              <a:rot lat="0" lon="0" rev="0"/>
+            </a:camera>
+            <a:lightRig rig="threePt" dir="t">
+              <a:rot lat="0" lon="0" rev="1200000"/>
+            </a:lightRig>
+          </a:scene3d>
+          <a:sp3d>
+            <a:bevelT w="63500" h="25400"/>
+          </a:sp3d>
+        </a:effectStyle>
+      </a:effectStyleLst>
+      <a:bgFillStyleLst>
+        <a:solidFill>
+          <a:schemeClr val="phClr"/>
+        </a:solidFill>
+        <a:gradFill rotWithShape="1">
+          <a:gsLst>
+            <a:gs pos="0">
+              <a:schemeClr val="phClr">
+                <a:tint val="40000"/>
+                <a:satMod val="350000"/>
+              </a:schemeClr>
+            </a:gs>
+            <a:gs pos="40000">
+              <a:schemeClr val="phClr">
+                <a:tint val="45000"/>
+                <a:shade val="99000"/>
+                <a:satMod val="350000"/>
+              </a:schemeClr>
+            </a:gs>
+            <a:gs pos="100000">
+              <a:schemeClr val="phClr">
+                <a:shade val="20000"/>
+                <a:satMod val="255000"/>
+              </a:schemeClr>
+            </a:gs>
+          </a:gsLst>
+          <a:path path="circle">
+            <a:fillToRect l="50000" t="-80000" r="50000" b="180000"/>
+          </a:path>
+        </a:gradFill>
+        <a:gradFill rotWithShape="1">
+          <a:gsLst>
+            <a:gs pos="0">
+              <a:schemeClr val="phClr">
+                <a:tint val="80000"/>
+                <a:satMod val="300000"/>
+              </a:schemeClr>
+            </a:gs>
+            <a:gs pos="100000">
+              <a:schemeClr val="phClr">
+                <a:shade val="30000"/>
+                <a:satMod val="200000"/>
+              </a:schemeClr>
+            </a:gs>
+          </a:gsLst>
+          <a:path path="circle">
+            <a:fillToRect l="50000" t="50000" r="50000" b="50000"/>
+          </a:path>
+        </a:gradFill>
+      </a:bgFillStyleLst>
+    </a:fmtScheme>
+  </a:themeElements>
+  <a:objectDefaults>
+    <a:spDef>
+      <a:spPr/>
+      <a:bodyPr/>
+      <a:lstStyle/>
+      <a:style>
+        <a:lnRef idx="1">
+          <a:schemeClr val="accent1"/>
+        </a:lnRef>
+        <a:fillRef idx="3">
+          <a:schemeClr val="accent1"/>
+        </a:fillRef>
+        <a:effectRef idx="2">
+          <a:schemeClr val="accent1"/>
+        </a:effectRef>
+        <a:fontRef idx="minor">
+          <a:schemeClr val="lt1"/>
+        </a:fontRef>
+      </a:style>
+    </a:spDef>
+    <a:lnDef>
+      <a:spPr/>
+      <a:bodyPr/>
+      <a:lstStyle/>
+      <a:style>
+        <a:lnRef idx="2">
+          <a:schemeClr val="accent1"/>
+        </a:lnRef>
+        <a:fillRef idx="0">
+          <a:schemeClr val="accent1"/>
+        </a:fillRef>
+        <a:effectRef idx="1">
+          <a:schemeClr val="accent1"/>
+        </a:effectRef>
+        <a:fontRef idx="minor">
+          <a:schemeClr val="tx1"/>
+        </a:fontRef>
+      </a:style>
+    </a:lnDef>
+  </a:objectDefaults>
+  <a:extraClrSchemeLst/>
+</a:theme>
 </file>
</xml_diff>